<commit_message>
Removed old demo time slides
</commit_message>
<xml_diff>
--- a/.demo/ESPC25_SPFx_Slides.pptx
+++ b/.demo/ESPC25_SPFx_Slides.pptx
@@ -8,7 +8,7 @@
     <p:sldMasterId id="2147483684" r:id="rId7"/>
   </p:sldMasterIdLst>
   <p:notesMasterIdLst>
-    <p:notesMasterId r:id="rId25"/>
+    <p:notesMasterId r:id="rId21"/>
   </p:notesMasterIdLst>
   <p:sldIdLst>
     <p:sldId id="256" r:id="rId8"/>
@@ -17,17 +17,13 @@
     <p:sldId id="261" r:id="rId11"/>
     <p:sldId id="274" r:id="rId12"/>
     <p:sldId id="285" r:id="rId13"/>
-    <p:sldId id="278" r:id="rId14"/>
+    <p:sldId id="286" r:id="rId14"/>
     <p:sldId id="275" r:id="rId15"/>
-    <p:sldId id="279" r:id="rId16"/>
-    <p:sldId id="276" r:id="rId17"/>
-    <p:sldId id="280" r:id="rId18"/>
-    <p:sldId id="277" r:id="rId19"/>
-    <p:sldId id="282" r:id="rId20"/>
-    <p:sldId id="283" r:id="rId21"/>
-    <p:sldId id="284" r:id="rId22"/>
-    <p:sldId id="281" r:id="rId23"/>
-    <p:sldId id="273" r:id="rId24"/>
+    <p:sldId id="276" r:id="rId16"/>
+    <p:sldId id="277" r:id="rId17"/>
+    <p:sldId id="283" r:id="rId18"/>
+    <p:sldId id="281" r:id="rId19"/>
+    <p:sldId id="273" r:id="rId20"/>
   </p:sldIdLst>
   <p:sldSz cx="12192000" cy="6858000"/>
   <p:notesSz cx="6858000" cy="9144000"/>
@@ -1075,790 +1071,6 @@
         <p:cNvPr id="1" name="">
           <a:extLst>
             <a:ext uri="{FF2B5EF4-FFF2-40B4-BE49-F238E27FC236}">
-              <a16:creationId xmlns:a16="http://schemas.microsoft.com/office/drawing/2014/main" id="{0023F4EE-5668-9285-4B73-8EBC843A05AB}"/>
-            </a:ext>
-          </a:extLst>
-        </p:cNvPr>
-        <p:cNvGrpSpPr/>
-        <p:nvPr/>
-      </p:nvGrpSpPr>
-      <p:grpSpPr>
-        <a:xfrm>
-          <a:off x="0" y="0"/>
-          <a:ext cx="0" cy="0"/>
-          <a:chOff x="0" y="0"/>
-          <a:chExt cx="0" cy="0"/>
-        </a:xfrm>
-      </p:grpSpPr>
-      <p:sp>
-        <p:nvSpPr>
-          <p:cNvPr id="2" name="Slide Image Placeholder 1">
-            <a:extLst>
-              <a:ext uri="{FF2B5EF4-FFF2-40B4-BE49-F238E27FC236}">
-                <a16:creationId xmlns:a16="http://schemas.microsoft.com/office/drawing/2014/main" id="{C01EC2A8-F0C7-F4A1-B109-E0297E4C5B58}"/>
-              </a:ext>
-            </a:extLst>
-          </p:cNvPr>
-          <p:cNvSpPr>
-            <a:spLocks noGrp="1" noRot="1" noChangeAspect="1"/>
-          </p:cNvSpPr>
-          <p:nvPr>
-            <p:ph type="sldImg"/>
-          </p:nvPr>
-        </p:nvSpPr>
-        <p:spPr/>
-      </p:sp>
-      <p:sp>
-        <p:nvSpPr>
-          <p:cNvPr id="3" name="Notes Placeholder 2">
-            <a:extLst>
-              <a:ext uri="{FF2B5EF4-FFF2-40B4-BE49-F238E27FC236}">
-                <a16:creationId xmlns:a16="http://schemas.microsoft.com/office/drawing/2014/main" id="{B8BF611D-1BCF-DBDD-C050-F6D145728FA0}"/>
-              </a:ext>
-            </a:extLst>
-          </p:cNvPr>
-          <p:cNvSpPr>
-            <a:spLocks noGrp="1"/>
-          </p:cNvSpPr>
-          <p:nvPr>
-            <p:ph type="body" idx="1"/>
-          </p:nvPr>
-        </p:nvSpPr>
-        <p:spPr/>
-        <p:txBody>
-          <a:bodyPr/>
-          <a:lstStyle/>
-          <a:p>
-            <a:endParaRPr lang="en-US"/>
-          </a:p>
-        </p:txBody>
-      </p:sp>
-      <p:sp>
-        <p:nvSpPr>
-          <p:cNvPr id="4" name="Slide Number Placeholder 3">
-            <a:extLst>
-              <a:ext uri="{FF2B5EF4-FFF2-40B4-BE49-F238E27FC236}">
-                <a16:creationId xmlns:a16="http://schemas.microsoft.com/office/drawing/2014/main" id="{73D21354-4A05-B689-9220-13769DB891BC}"/>
-              </a:ext>
-            </a:extLst>
-          </p:cNvPr>
-          <p:cNvSpPr>
-            <a:spLocks noGrp="1"/>
-          </p:cNvSpPr>
-          <p:nvPr>
-            <p:ph type="sldNum" sz="quarter" idx="5"/>
-          </p:nvPr>
-        </p:nvSpPr>
-        <p:spPr/>
-        <p:txBody>
-          <a:bodyPr/>
-          <a:lstStyle/>
-          <a:p>
-            <a:fld id="{7EB8C794-77EE-4724-B493-2E0907BFA558}" type="slidenum">
-              <a:rPr lang="en-GB" smtClean="0"/>
-              <a:t>11</a:t>
-            </a:fld>
-            <a:endParaRPr lang="en-GB"/>
-          </a:p>
-        </p:txBody>
-      </p:sp>
-    </p:spTree>
-    <p:extLst>
-      <p:ext uri="{BB962C8B-B14F-4D97-AF65-F5344CB8AC3E}">
-        <p14:creationId xmlns:p14="http://schemas.microsoft.com/office/powerpoint/2010/main" val="788871678"/>
-      </p:ext>
-    </p:extLst>
-  </p:cSld>
-  <p:clrMapOvr>
-    <a:masterClrMapping/>
-  </p:clrMapOvr>
-</p:notes>
-</file>
-
-<file path=ppt/notesSlides/notesSlide11.xml><?xml version="1.0" encoding="utf-8"?>
-<p:notes xmlns:a="http://schemas.openxmlformats.org/drawingml/2006/main" xmlns:r="http://schemas.openxmlformats.org/officeDocument/2006/relationships" xmlns:p="http://schemas.openxmlformats.org/presentationml/2006/main">
-  <p:cSld>
-    <p:spTree>
-      <p:nvGrpSpPr>
-        <p:cNvPr id="1" name="">
-          <a:extLst>
-            <a:ext uri="{FF2B5EF4-FFF2-40B4-BE49-F238E27FC236}">
-              <a16:creationId xmlns:a16="http://schemas.microsoft.com/office/drawing/2014/main" id="{E5E34A03-EDDC-496B-A252-C7FFBF6910FF}"/>
-            </a:ext>
-          </a:extLst>
-        </p:cNvPr>
-        <p:cNvGrpSpPr/>
-        <p:nvPr/>
-      </p:nvGrpSpPr>
-      <p:grpSpPr>
-        <a:xfrm>
-          <a:off x="0" y="0"/>
-          <a:ext cx="0" cy="0"/>
-          <a:chOff x="0" y="0"/>
-          <a:chExt cx="0" cy="0"/>
-        </a:xfrm>
-      </p:grpSpPr>
-      <p:sp>
-        <p:nvSpPr>
-          <p:cNvPr id="2" name="Slide Image Placeholder 1">
-            <a:extLst>
-              <a:ext uri="{FF2B5EF4-FFF2-40B4-BE49-F238E27FC236}">
-                <a16:creationId xmlns:a16="http://schemas.microsoft.com/office/drawing/2014/main" id="{48A9EF52-BEF5-A1DD-9400-B0F6CF9FCB38}"/>
-              </a:ext>
-            </a:extLst>
-          </p:cNvPr>
-          <p:cNvSpPr>
-            <a:spLocks noGrp="1" noRot="1" noChangeAspect="1"/>
-          </p:cNvSpPr>
-          <p:nvPr>
-            <p:ph type="sldImg"/>
-          </p:nvPr>
-        </p:nvSpPr>
-        <p:spPr/>
-      </p:sp>
-      <p:sp>
-        <p:nvSpPr>
-          <p:cNvPr id="3" name="Notes Placeholder 2">
-            <a:extLst>
-              <a:ext uri="{FF2B5EF4-FFF2-40B4-BE49-F238E27FC236}">
-                <a16:creationId xmlns:a16="http://schemas.microsoft.com/office/drawing/2014/main" id="{9CD63604-03EE-C33D-885B-D60B1D085275}"/>
-              </a:ext>
-            </a:extLst>
-          </p:cNvPr>
-          <p:cNvSpPr>
-            <a:spLocks noGrp="1"/>
-          </p:cNvSpPr>
-          <p:nvPr>
-            <p:ph type="body" idx="1"/>
-          </p:nvPr>
-        </p:nvSpPr>
-        <p:spPr/>
-        <p:txBody>
-          <a:bodyPr/>
-          <a:lstStyle/>
-          <a:p>
-            <a:r>
-              <a:rPr lang="en-US" dirty="0">
-                <a:ea typeface="Calibri"/>
-                <a:cs typeface="Calibri"/>
-              </a:rPr>
-              <a:t>How often do we use tests in our projects?</a:t>
-            </a:r>
-          </a:p>
-          <a:p>
-            <a:r>
-              <a:rPr lang="en-US">
-                <a:ea typeface="Calibri"/>
-                <a:cs typeface="Calibri"/>
-              </a:rPr>
-              <a:t>It depends on:</a:t>
-            </a:r>
-          </a:p>
-          <a:p>
-            <a:pPr marL="171450" indent="-171450">
-              <a:buFont typeface="Calibri"/>
-              <a:buChar char="-"/>
-            </a:pPr>
-            <a:r>
-              <a:rPr lang="en-US" dirty="0">
-                <a:ea typeface="Calibri"/>
-                <a:cs typeface="Calibri"/>
-              </a:rPr>
-              <a:t>Budget</a:t>
-            </a:r>
-          </a:p>
-          <a:p>
-            <a:pPr marL="171450" indent="-171450">
-              <a:buFont typeface="Calibri"/>
-              <a:buChar char="-"/>
-            </a:pPr>
-            <a:r>
-              <a:rPr lang="en-US" dirty="0">
-                <a:ea typeface="Calibri"/>
-                <a:cs typeface="Calibri"/>
-              </a:rPr>
-              <a:t>Timing</a:t>
-            </a:r>
-          </a:p>
-          <a:p>
-            <a:pPr marL="171450" indent="-171450">
-              <a:buFont typeface="Calibri"/>
-              <a:buChar char="-"/>
-            </a:pPr>
-            <a:r>
-              <a:rPr lang="en-US" dirty="0">
-                <a:ea typeface="Calibri"/>
-                <a:cs typeface="Calibri"/>
-              </a:rPr>
-              <a:t>Customers says it's not needed</a:t>
-            </a:r>
-          </a:p>
-          <a:p>
-            <a:endParaRPr lang="en-US" dirty="0">
-              <a:ea typeface="Calibri"/>
-              <a:cs typeface="Calibri"/>
-            </a:endParaRPr>
-          </a:p>
-          <a:p>
-            <a:r>
-              <a:rPr lang="en-US" dirty="0">
-                <a:ea typeface="Calibri"/>
-                <a:cs typeface="Calibri"/>
-              </a:rPr>
-              <a:t>Giveaways</a:t>
-            </a:r>
-          </a:p>
-          <a:p>
-            <a:pPr marL="171450" indent="-171450">
-              <a:buFont typeface="Calibri"/>
-              <a:buChar char="-"/>
-            </a:pPr>
-            <a:r>
-              <a:rPr lang="en-US" dirty="0">
-                <a:ea typeface="Calibri"/>
-                <a:cs typeface="Calibri"/>
-              </a:rPr>
-              <a:t>Unit tests saves can save our life and are responsible to have an expected behavior of your application over multiple deployments and changes.</a:t>
-            </a:r>
-          </a:p>
-          <a:p>
-            <a:pPr marL="171450" indent="-171450">
-              <a:buFont typeface="Calibri"/>
-              <a:buChar char="-"/>
-            </a:pPr>
-            <a:r>
-              <a:rPr lang="en-US" dirty="0">
-                <a:ea typeface="Calibri"/>
-                <a:cs typeface="Calibri"/>
-              </a:rPr>
-              <a:t>Who writes the code should not test it but leave it to another person of the team</a:t>
-            </a:r>
-          </a:p>
-          <a:p>
-            <a:pPr marL="171450" indent="-171450">
-              <a:buFont typeface="Calibri"/>
-              <a:buChar char="-"/>
-            </a:pPr>
-            <a:endParaRPr lang="en-US" dirty="0">
-              <a:ea typeface="Calibri"/>
-              <a:cs typeface="Calibri"/>
-            </a:endParaRPr>
-          </a:p>
-          <a:p>
-            <a:pPr marL="171450" indent="-171450">
-              <a:buFont typeface="Calibri"/>
-              <a:buChar char="-"/>
-            </a:pPr>
-            <a:endParaRPr lang="en-US" dirty="0">
-              <a:ea typeface="Calibri"/>
-              <a:cs typeface="Calibri"/>
-            </a:endParaRPr>
-          </a:p>
-        </p:txBody>
-      </p:sp>
-      <p:sp>
-        <p:nvSpPr>
-          <p:cNvPr id="4" name="Slide Number Placeholder 3">
-            <a:extLst>
-              <a:ext uri="{FF2B5EF4-FFF2-40B4-BE49-F238E27FC236}">
-                <a16:creationId xmlns:a16="http://schemas.microsoft.com/office/drawing/2014/main" id="{C242478F-627E-D87B-5821-E7FA3AAFEC44}"/>
-              </a:ext>
-            </a:extLst>
-          </p:cNvPr>
-          <p:cNvSpPr>
-            <a:spLocks noGrp="1"/>
-          </p:cNvSpPr>
-          <p:nvPr>
-            <p:ph type="sldNum" sz="quarter" idx="5"/>
-          </p:nvPr>
-        </p:nvSpPr>
-        <p:spPr/>
-        <p:txBody>
-          <a:bodyPr/>
-          <a:lstStyle/>
-          <a:p>
-            <a:fld id="{7EB8C794-77EE-4724-B493-2E0907BFA558}" type="slidenum">
-              <a:rPr lang="en-GB" smtClean="0"/>
-              <a:t>12</a:t>
-            </a:fld>
-            <a:endParaRPr lang="en-GB"/>
-          </a:p>
-        </p:txBody>
-      </p:sp>
-    </p:spTree>
-    <p:extLst>
-      <p:ext uri="{BB962C8B-B14F-4D97-AF65-F5344CB8AC3E}">
-        <p14:creationId xmlns:p14="http://schemas.microsoft.com/office/powerpoint/2010/main" val="2612603715"/>
-      </p:ext>
-    </p:extLst>
-  </p:cSld>
-  <p:clrMapOvr>
-    <a:masterClrMapping/>
-  </p:clrMapOvr>
-</p:notes>
-</file>
-
-<file path=ppt/notesSlides/notesSlide12.xml><?xml version="1.0" encoding="utf-8"?>
-<p:notes xmlns:a="http://schemas.openxmlformats.org/drawingml/2006/main" xmlns:r="http://schemas.openxmlformats.org/officeDocument/2006/relationships" xmlns:p="http://schemas.openxmlformats.org/presentationml/2006/main">
-  <p:cSld>
-    <p:spTree>
-      <p:nvGrpSpPr>
-        <p:cNvPr id="1" name="">
-          <a:extLst>
-            <a:ext uri="{FF2B5EF4-FFF2-40B4-BE49-F238E27FC236}">
-              <a16:creationId xmlns:a16="http://schemas.microsoft.com/office/drawing/2014/main" id="{A493CA4D-7E14-2800-0583-DD0B38E8D7B3}"/>
-            </a:ext>
-          </a:extLst>
-        </p:cNvPr>
-        <p:cNvGrpSpPr/>
-        <p:nvPr/>
-      </p:nvGrpSpPr>
-      <p:grpSpPr>
-        <a:xfrm>
-          <a:off x="0" y="0"/>
-          <a:ext cx="0" cy="0"/>
-          <a:chOff x="0" y="0"/>
-          <a:chExt cx="0" cy="0"/>
-        </a:xfrm>
-      </p:grpSpPr>
-      <p:sp>
-        <p:nvSpPr>
-          <p:cNvPr id="2" name="Slide Image Placeholder 1">
-            <a:extLst>
-              <a:ext uri="{FF2B5EF4-FFF2-40B4-BE49-F238E27FC236}">
-                <a16:creationId xmlns:a16="http://schemas.microsoft.com/office/drawing/2014/main" id="{12DD0095-F60D-2C41-9EDA-8B28885687FC}"/>
-              </a:ext>
-            </a:extLst>
-          </p:cNvPr>
-          <p:cNvSpPr>
-            <a:spLocks noGrp="1" noRot="1" noChangeAspect="1"/>
-          </p:cNvSpPr>
-          <p:nvPr>
-            <p:ph type="sldImg"/>
-          </p:nvPr>
-        </p:nvSpPr>
-        <p:spPr/>
-      </p:sp>
-      <p:sp>
-        <p:nvSpPr>
-          <p:cNvPr id="3" name="Notes Placeholder 2">
-            <a:extLst>
-              <a:ext uri="{FF2B5EF4-FFF2-40B4-BE49-F238E27FC236}">
-                <a16:creationId xmlns:a16="http://schemas.microsoft.com/office/drawing/2014/main" id="{EF516803-58C8-3F40-5AAA-CEC1FC1D4C15}"/>
-              </a:ext>
-            </a:extLst>
-          </p:cNvPr>
-          <p:cNvSpPr>
-            <a:spLocks noGrp="1"/>
-          </p:cNvSpPr>
-          <p:nvPr>
-            <p:ph type="body" idx="1"/>
-          </p:nvPr>
-        </p:nvSpPr>
-        <p:spPr/>
-        <p:txBody>
-          <a:bodyPr/>
-          <a:lstStyle/>
-          <a:p>
-            <a:pPr marL="171450" indent="-171450">
-              <a:buFont typeface="Calibri"/>
-              <a:buChar char="-"/>
-            </a:pPr>
-            <a:endParaRPr lang="en-US" dirty="0">
-              <a:ea typeface="Calibri"/>
-              <a:cs typeface="Calibri"/>
-            </a:endParaRPr>
-          </a:p>
-        </p:txBody>
-      </p:sp>
-      <p:sp>
-        <p:nvSpPr>
-          <p:cNvPr id="4" name="Slide Number Placeholder 3">
-            <a:extLst>
-              <a:ext uri="{FF2B5EF4-FFF2-40B4-BE49-F238E27FC236}">
-                <a16:creationId xmlns:a16="http://schemas.microsoft.com/office/drawing/2014/main" id="{45FEDAD8-A81E-C5AC-22ED-6AB4F974DF91}"/>
-              </a:ext>
-            </a:extLst>
-          </p:cNvPr>
-          <p:cNvSpPr>
-            <a:spLocks noGrp="1"/>
-          </p:cNvSpPr>
-          <p:nvPr>
-            <p:ph type="sldNum" sz="quarter" idx="5"/>
-          </p:nvPr>
-        </p:nvSpPr>
-        <p:spPr/>
-        <p:txBody>
-          <a:bodyPr/>
-          <a:lstStyle/>
-          <a:p>
-            <a:fld id="{7EB8C794-77EE-4724-B493-2E0907BFA558}" type="slidenum">
-              <a:rPr lang="en-GB" smtClean="0"/>
-              <a:t>13</a:t>
-            </a:fld>
-            <a:endParaRPr lang="en-GB"/>
-          </a:p>
-        </p:txBody>
-      </p:sp>
-    </p:spTree>
-    <p:extLst>
-      <p:ext uri="{BB962C8B-B14F-4D97-AF65-F5344CB8AC3E}">
-        <p14:creationId xmlns:p14="http://schemas.microsoft.com/office/powerpoint/2010/main" val="3169937132"/>
-      </p:ext>
-    </p:extLst>
-  </p:cSld>
-  <p:clrMapOvr>
-    <a:masterClrMapping/>
-  </p:clrMapOvr>
-</p:notes>
-</file>
-
-<file path=ppt/notesSlides/notesSlide13.xml><?xml version="1.0" encoding="utf-8"?>
-<p:notes xmlns:a="http://schemas.openxmlformats.org/drawingml/2006/main" xmlns:r="http://schemas.openxmlformats.org/officeDocument/2006/relationships" xmlns:p="http://schemas.openxmlformats.org/presentationml/2006/main">
-  <p:cSld>
-    <p:spTree>
-      <p:nvGrpSpPr>
-        <p:cNvPr id="1" name="">
-          <a:extLst>
-            <a:ext uri="{FF2B5EF4-FFF2-40B4-BE49-F238E27FC236}">
-              <a16:creationId xmlns:a16="http://schemas.microsoft.com/office/drawing/2014/main" id="{2D45DC49-A269-D24C-E4C8-75E5BCE198F7}"/>
-            </a:ext>
-          </a:extLst>
-        </p:cNvPr>
-        <p:cNvGrpSpPr/>
-        <p:nvPr/>
-      </p:nvGrpSpPr>
-      <p:grpSpPr>
-        <a:xfrm>
-          <a:off x="0" y="0"/>
-          <a:ext cx="0" cy="0"/>
-          <a:chOff x="0" y="0"/>
-          <a:chExt cx="0" cy="0"/>
-        </a:xfrm>
-      </p:grpSpPr>
-      <p:sp>
-        <p:nvSpPr>
-          <p:cNvPr id="2" name="Slide Image Placeholder 1">
-            <a:extLst>
-              <a:ext uri="{FF2B5EF4-FFF2-40B4-BE49-F238E27FC236}">
-                <a16:creationId xmlns:a16="http://schemas.microsoft.com/office/drawing/2014/main" id="{722FAF7C-28B0-293F-58BE-68267837BDBE}"/>
-              </a:ext>
-            </a:extLst>
-          </p:cNvPr>
-          <p:cNvSpPr>
-            <a:spLocks noGrp="1" noRot="1" noChangeAspect="1"/>
-          </p:cNvSpPr>
-          <p:nvPr>
-            <p:ph type="sldImg"/>
-          </p:nvPr>
-        </p:nvSpPr>
-        <p:spPr/>
-      </p:sp>
-      <p:sp>
-        <p:nvSpPr>
-          <p:cNvPr id="3" name="Notes Placeholder 2">
-            <a:extLst>
-              <a:ext uri="{FF2B5EF4-FFF2-40B4-BE49-F238E27FC236}">
-                <a16:creationId xmlns:a16="http://schemas.microsoft.com/office/drawing/2014/main" id="{66A4D9B9-AA9D-7422-0FFE-2998DA32119B}"/>
-              </a:ext>
-            </a:extLst>
-          </p:cNvPr>
-          <p:cNvSpPr>
-            <a:spLocks noGrp="1"/>
-          </p:cNvSpPr>
-          <p:nvPr>
-            <p:ph type="body" idx="1"/>
-          </p:nvPr>
-        </p:nvSpPr>
-        <p:spPr/>
-        <p:txBody>
-          <a:bodyPr/>
-          <a:lstStyle/>
-          <a:p>
-            <a:r>
-              <a:rPr lang="en-US" dirty="0">
-                <a:ea typeface="Calibri"/>
-                <a:cs typeface="Calibri"/>
-              </a:rPr>
-              <a:t>How often do we use tests in our projects?</a:t>
-            </a:r>
-          </a:p>
-          <a:p>
-            <a:r>
-              <a:rPr lang="en-US">
-                <a:ea typeface="Calibri"/>
-                <a:cs typeface="Calibri"/>
-              </a:rPr>
-              <a:t>It depends on:</a:t>
-            </a:r>
-          </a:p>
-          <a:p>
-            <a:pPr marL="171450" indent="-171450">
-              <a:buFont typeface="Calibri"/>
-              <a:buChar char="-"/>
-            </a:pPr>
-            <a:r>
-              <a:rPr lang="en-US" dirty="0">
-                <a:ea typeface="Calibri"/>
-                <a:cs typeface="Calibri"/>
-              </a:rPr>
-              <a:t>Budget</a:t>
-            </a:r>
-          </a:p>
-          <a:p>
-            <a:pPr marL="171450" indent="-171450">
-              <a:buFont typeface="Calibri"/>
-              <a:buChar char="-"/>
-            </a:pPr>
-            <a:r>
-              <a:rPr lang="en-US" dirty="0">
-                <a:ea typeface="Calibri"/>
-                <a:cs typeface="Calibri"/>
-              </a:rPr>
-              <a:t>Timing</a:t>
-            </a:r>
-          </a:p>
-          <a:p>
-            <a:pPr marL="171450" indent="-171450">
-              <a:buFont typeface="Calibri"/>
-              <a:buChar char="-"/>
-            </a:pPr>
-            <a:r>
-              <a:rPr lang="en-US" dirty="0">
-                <a:ea typeface="Calibri"/>
-                <a:cs typeface="Calibri"/>
-              </a:rPr>
-              <a:t>Customers says it's not needed</a:t>
-            </a:r>
-          </a:p>
-          <a:p>
-            <a:endParaRPr lang="en-US" dirty="0">
-              <a:ea typeface="Calibri"/>
-              <a:cs typeface="Calibri"/>
-            </a:endParaRPr>
-          </a:p>
-          <a:p>
-            <a:r>
-              <a:rPr lang="en-US" dirty="0">
-                <a:ea typeface="Calibri"/>
-                <a:cs typeface="Calibri"/>
-              </a:rPr>
-              <a:t>Giveaways</a:t>
-            </a:r>
-          </a:p>
-          <a:p>
-            <a:pPr marL="171450" indent="-171450">
-              <a:buFont typeface="Calibri"/>
-              <a:buChar char="-"/>
-            </a:pPr>
-            <a:r>
-              <a:rPr lang="en-US" dirty="0">
-                <a:ea typeface="Calibri"/>
-                <a:cs typeface="Calibri"/>
-              </a:rPr>
-              <a:t>Unit tests saves can save our life and are responsible to have an expected behavior of your application over multiple deployments and changes.</a:t>
-            </a:r>
-          </a:p>
-          <a:p>
-            <a:pPr marL="171450" indent="-171450">
-              <a:buFont typeface="Calibri"/>
-              <a:buChar char="-"/>
-            </a:pPr>
-            <a:r>
-              <a:rPr lang="en-US" dirty="0">
-                <a:ea typeface="Calibri"/>
-                <a:cs typeface="Calibri"/>
-              </a:rPr>
-              <a:t>Who writes the code should not test it but leave it to another person of the team</a:t>
-            </a:r>
-          </a:p>
-          <a:p>
-            <a:pPr marL="171450" indent="-171450">
-              <a:buFont typeface="Calibri"/>
-              <a:buChar char="-"/>
-            </a:pPr>
-            <a:endParaRPr lang="en-US" dirty="0">
-              <a:ea typeface="Calibri"/>
-              <a:cs typeface="Calibri"/>
-            </a:endParaRPr>
-          </a:p>
-          <a:p>
-            <a:pPr marL="171450" indent="-171450">
-              <a:buFont typeface="Calibri"/>
-              <a:buChar char="-"/>
-            </a:pPr>
-            <a:endParaRPr lang="en-US" dirty="0">
-              <a:ea typeface="Calibri"/>
-              <a:cs typeface="Calibri"/>
-            </a:endParaRPr>
-          </a:p>
-        </p:txBody>
-      </p:sp>
-      <p:sp>
-        <p:nvSpPr>
-          <p:cNvPr id="4" name="Slide Number Placeholder 3">
-            <a:extLst>
-              <a:ext uri="{FF2B5EF4-FFF2-40B4-BE49-F238E27FC236}">
-                <a16:creationId xmlns:a16="http://schemas.microsoft.com/office/drawing/2014/main" id="{0D40BFFB-821F-4B9A-38C5-7DC704AF23EB}"/>
-              </a:ext>
-            </a:extLst>
-          </p:cNvPr>
-          <p:cNvSpPr>
-            <a:spLocks noGrp="1"/>
-          </p:cNvSpPr>
-          <p:nvPr>
-            <p:ph type="sldNum" sz="quarter" idx="5"/>
-          </p:nvPr>
-        </p:nvSpPr>
-        <p:spPr/>
-        <p:txBody>
-          <a:bodyPr/>
-          <a:lstStyle/>
-          <a:p>
-            <a:fld id="{7EB8C794-77EE-4724-B493-2E0907BFA558}" type="slidenum">
-              <a:rPr lang="en-GB" smtClean="0"/>
-              <a:t>14</a:t>
-            </a:fld>
-            <a:endParaRPr lang="en-GB"/>
-          </a:p>
-        </p:txBody>
-      </p:sp>
-    </p:spTree>
-    <p:extLst>
-      <p:ext uri="{BB962C8B-B14F-4D97-AF65-F5344CB8AC3E}">
-        <p14:creationId xmlns:p14="http://schemas.microsoft.com/office/powerpoint/2010/main" val="1301111360"/>
-      </p:ext>
-    </p:extLst>
-  </p:cSld>
-  <p:clrMapOvr>
-    <a:masterClrMapping/>
-  </p:clrMapOvr>
-</p:notes>
-</file>
-
-<file path=ppt/notesSlides/notesSlide14.xml><?xml version="1.0" encoding="utf-8"?>
-<p:notes xmlns:a="http://schemas.openxmlformats.org/drawingml/2006/main" xmlns:r="http://schemas.openxmlformats.org/officeDocument/2006/relationships" xmlns:p="http://schemas.openxmlformats.org/presentationml/2006/main">
-  <p:cSld>
-    <p:spTree>
-      <p:nvGrpSpPr>
-        <p:cNvPr id="1" name="">
-          <a:extLst>
-            <a:ext uri="{FF2B5EF4-FFF2-40B4-BE49-F238E27FC236}">
-              <a16:creationId xmlns:a16="http://schemas.microsoft.com/office/drawing/2014/main" id="{EFAE80E2-63DB-FCE2-C727-8D4FDE5FCD82}"/>
-            </a:ext>
-          </a:extLst>
-        </p:cNvPr>
-        <p:cNvGrpSpPr/>
-        <p:nvPr/>
-      </p:nvGrpSpPr>
-      <p:grpSpPr>
-        <a:xfrm>
-          <a:off x="0" y="0"/>
-          <a:ext cx="0" cy="0"/>
-          <a:chOff x="0" y="0"/>
-          <a:chExt cx="0" cy="0"/>
-        </a:xfrm>
-      </p:grpSpPr>
-      <p:sp>
-        <p:nvSpPr>
-          <p:cNvPr id="2" name="Slide Image Placeholder 1">
-            <a:extLst>
-              <a:ext uri="{FF2B5EF4-FFF2-40B4-BE49-F238E27FC236}">
-                <a16:creationId xmlns:a16="http://schemas.microsoft.com/office/drawing/2014/main" id="{1BBF3711-4E5E-C1F5-3FD3-FEDDF48A49A8}"/>
-              </a:ext>
-            </a:extLst>
-          </p:cNvPr>
-          <p:cNvSpPr>
-            <a:spLocks noGrp="1" noRot="1" noChangeAspect="1"/>
-          </p:cNvSpPr>
-          <p:nvPr>
-            <p:ph type="sldImg"/>
-          </p:nvPr>
-        </p:nvSpPr>
-        <p:spPr/>
-      </p:sp>
-      <p:sp>
-        <p:nvSpPr>
-          <p:cNvPr id="3" name="Notes Placeholder 2">
-            <a:extLst>
-              <a:ext uri="{FF2B5EF4-FFF2-40B4-BE49-F238E27FC236}">
-                <a16:creationId xmlns:a16="http://schemas.microsoft.com/office/drawing/2014/main" id="{34E75094-FBBD-4136-A93E-620C11F35268}"/>
-              </a:ext>
-            </a:extLst>
-          </p:cNvPr>
-          <p:cNvSpPr>
-            <a:spLocks noGrp="1"/>
-          </p:cNvSpPr>
-          <p:nvPr>
-            <p:ph type="body" idx="1"/>
-          </p:nvPr>
-        </p:nvSpPr>
-        <p:spPr/>
-        <p:txBody>
-          <a:bodyPr/>
-          <a:lstStyle/>
-          <a:p>
-            <a:pPr marL="171450" indent="-171450">
-              <a:buFont typeface="Calibri"/>
-              <a:buChar char="-"/>
-            </a:pPr>
-            <a:endParaRPr lang="en-US" dirty="0">
-              <a:ea typeface="Calibri"/>
-              <a:cs typeface="Calibri"/>
-            </a:endParaRPr>
-          </a:p>
-        </p:txBody>
-      </p:sp>
-      <p:sp>
-        <p:nvSpPr>
-          <p:cNvPr id="4" name="Slide Number Placeholder 3">
-            <a:extLst>
-              <a:ext uri="{FF2B5EF4-FFF2-40B4-BE49-F238E27FC236}">
-                <a16:creationId xmlns:a16="http://schemas.microsoft.com/office/drawing/2014/main" id="{253F40E7-4962-49A7-2F83-62E2E4535C5E}"/>
-              </a:ext>
-            </a:extLst>
-          </p:cNvPr>
-          <p:cNvSpPr>
-            <a:spLocks noGrp="1"/>
-          </p:cNvSpPr>
-          <p:nvPr>
-            <p:ph type="sldNum" sz="quarter" idx="5"/>
-          </p:nvPr>
-        </p:nvSpPr>
-        <p:spPr/>
-        <p:txBody>
-          <a:bodyPr/>
-          <a:lstStyle/>
-          <a:p>
-            <a:fld id="{7EB8C794-77EE-4724-B493-2E0907BFA558}" type="slidenum">
-              <a:rPr lang="en-GB" smtClean="0"/>
-              <a:t>15</a:t>
-            </a:fld>
-            <a:endParaRPr lang="en-GB"/>
-          </a:p>
-        </p:txBody>
-      </p:sp>
-    </p:spTree>
-    <p:extLst>
-      <p:ext uri="{BB962C8B-B14F-4D97-AF65-F5344CB8AC3E}">
-        <p14:creationId xmlns:p14="http://schemas.microsoft.com/office/powerpoint/2010/main" val="3547106509"/>
-      </p:ext>
-    </p:extLst>
-  </p:cSld>
-  <p:clrMapOvr>
-    <a:masterClrMapping/>
-  </p:clrMapOvr>
-</p:notes>
-</file>
-
-<file path=ppt/notesSlides/notesSlide15.xml><?xml version="1.0" encoding="utf-8"?>
-<p:notes xmlns:a="http://schemas.openxmlformats.org/drawingml/2006/main" xmlns:r="http://schemas.openxmlformats.org/officeDocument/2006/relationships" xmlns:p="http://schemas.openxmlformats.org/presentationml/2006/main">
-  <p:cSld>
-    <p:spTree>
-      <p:nvGrpSpPr>
-        <p:cNvPr id="1" name="">
-          <a:extLst>
-            <a:ext uri="{FF2B5EF4-FFF2-40B4-BE49-F238E27FC236}">
               <a16:creationId xmlns:a16="http://schemas.microsoft.com/office/drawing/2014/main" id="{57A32D5C-DF60-A326-82D2-59F7D398ADA0}"/>
             </a:ext>
           </a:extLst>
@@ -1923,7 +1135,7 @@
           </a:p>
           <a:p>
             <a:r>
-              <a:rPr lang="en-US">
+              <a:rPr lang="en-US" dirty="0">
                 <a:ea typeface="Calibri"/>
                 <a:cs typeface="Calibri"/>
               </a:rPr>
@@ -2008,6 +1220,47 @@
                 <a:cs typeface="Calibri"/>
               </a:rPr>
               <a:t>Who writes the code should not test it but leave it to another person of the team</a:t>
+            </a:r>
+          </a:p>
+          <a:p>
+            <a:pPr marL="171450" indent="-171450">
+              <a:buFont typeface="Calibri"/>
+              <a:buChar char="-"/>
+            </a:pPr>
+            <a:endParaRPr lang="en-US" dirty="0">
+              <a:ea typeface="Calibri"/>
+              <a:cs typeface="Calibri"/>
+            </a:endParaRPr>
+          </a:p>
+          <a:p>
+            <a:pPr marL="0" marR="0" lvl="0" indent="0" algn="l" defTabSz="914400" rtl="0" eaLnBrk="1" fontAlgn="auto" latinLnBrk="0" hangingPunct="1">
+              <a:lnSpc>
+                <a:spcPct val="100000"/>
+              </a:lnSpc>
+              <a:spcBef>
+                <a:spcPts val="0"/>
+              </a:spcBef>
+              <a:spcAft>
+                <a:spcPts val="0"/>
+              </a:spcAft>
+              <a:buClrTx/>
+              <a:buSzTx/>
+              <a:buFont typeface="Calibri"/>
+              <a:buNone/>
+              <a:tabLst/>
+              <a:defRPr/>
+            </a:pPr>
+            <a:r>
+              <a:rPr lang="en-US" sz="1200" kern="1200" dirty="0">
+                <a:solidFill>
+                  <a:schemeClr val="tx1"/>
+                </a:solidFill>
+                <a:effectLst/>
+                <a:latin typeface="+mn-lt"/>
+                <a:ea typeface="+mn-ea"/>
+                <a:cs typeface="+mn-cs"/>
+              </a:rPr>
+              <a:t>The provided repo is public for audience use and learning: https://github.com/GuidoZam/espc-spfx-session-demo</a:t>
             </a:r>
           </a:p>
           <a:p>
@@ -2055,7 +1308,7 @@
           <a:p>
             <a:fld id="{7EB8C794-77EE-4724-B493-2E0907BFA558}" type="slidenum">
               <a:rPr lang="en-GB" smtClean="0"/>
-              <a:t>16</a:t>
+              <a:t>12</a:t>
             </a:fld>
             <a:endParaRPr lang="en-GB"/>
           </a:p>
@@ -2074,7 +1327,7 @@
 </p:notes>
 </file>
 
-<file path=ppt/notesSlides/notesSlide16.xml><?xml version="1.0" encoding="utf-8"?>
+<file path=ppt/notesSlides/notesSlide11.xml><?xml version="1.0" encoding="utf-8"?>
 <p:notes xmlns:a="http://schemas.openxmlformats.org/drawingml/2006/main" xmlns:r="http://schemas.openxmlformats.org/officeDocument/2006/relationships" xmlns:p="http://schemas.openxmlformats.org/presentationml/2006/main">
   <p:cSld>
     <p:spTree>
@@ -2147,7 +1400,7 @@
           <a:p>
             <a:fld id="{7EB8C794-77EE-4724-B493-2E0907BFA558}" type="slidenum">
               <a:rPr lang="en-GB" smtClean="0"/>
-              <a:t>17</a:t>
+              <a:t>13</a:t>
             </a:fld>
             <a:endParaRPr lang="en-GB"/>
           </a:p>
@@ -2781,53 +2034,8 @@
                 <a:ea typeface="+mn-ea"/>
                 <a:cs typeface="+mn-cs"/>
               </a:rPr>
-              <a:t>: GitHub Actions automate environment setup, dependency installation, solution bundling, unit tests, packaging, deployment, and UI tests. </a:t>
-            </a:r>
-            <a:r>
-              <a:rPr lang="en-US" sz="1200" kern="1200">
-                <a:solidFill>
-                  <a:schemeClr val="tx1"/>
-                </a:solidFill>
-                <a:effectLst/>
-                <a:latin typeface="+mn-lt"/>
-                <a:ea typeface="+mn-ea"/>
-                <a:cs typeface="+mn-cs"/>
-              </a:rPr>
-              <a:t>Secrets </a:t>
-            </a:r>
-            <a:r>
-              <a:rPr lang="en-US" sz="1200" kern="1200" dirty="0">
-                <a:solidFill>
-                  <a:schemeClr val="tx1"/>
-                </a:solidFill>
-                <a:effectLst/>
-                <a:latin typeface="+mn-lt"/>
-                <a:ea typeface="+mn-ea"/>
-                <a:cs typeface="+mn-cs"/>
-              </a:rPr>
-              <a:t>and environment variables are managed for </a:t>
-            </a:r>
-            <a:r>
-              <a:rPr lang="en-US" sz="1200" kern="1200">
-                <a:solidFill>
-                  <a:schemeClr val="tx1"/>
-                </a:solidFill>
-                <a:effectLst/>
-                <a:latin typeface="+mn-lt"/>
-                <a:ea typeface="+mn-ea"/>
-                <a:cs typeface="+mn-cs"/>
-              </a:rPr>
-              <a:t>security.</a:t>
-            </a:r>
-            <a:endParaRPr lang="en-US" sz="1200" kern="1200" dirty="0">
-              <a:solidFill>
-                <a:schemeClr val="tx1"/>
-              </a:solidFill>
-              <a:effectLst/>
-              <a:latin typeface="+mn-lt"/>
-              <a:ea typeface="+mn-ea"/>
-              <a:cs typeface="+mn-cs"/>
-            </a:endParaRPr>
+              <a:t>: GitHub Actions automate environment setup, dependency installation, solution bundling, unit tests, packaging, deployment, and UI tests. Secrets and environment variables are managed for security.</a:t>
+            </a:r>
           </a:p>
           <a:p>
             <a:endParaRPr lang="en-US" sz="1200" kern="1200" dirty="0">
@@ -2896,114 +2104,6 @@
 </file>
 
 <file path=ppt/notesSlides/notesSlide6.xml><?xml version="1.0" encoding="utf-8"?>
-<p:notes xmlns:a="http://schemas.openxmlformats.org/drawingml/2006/main" xmlns:r="http://schemas.openxmlformats.org/officeDocument/2006/relationships" xmlns:p="http://schemas.openxmlformats.org/presentationml/2006/main">
-  <p:cSld>
-    <p:spTree>
-      <p:nvGrpSpPr>
-        <p:cNvPr id="1" name="">
-          <a:extLst>
-            <a:ext uri="{FF2B5EF4-FFF2-40B4-BE49-F238E27FC236}">
-              <a16:creationId xmlns:a16="http://schemas.microsoft.com/office/drawing/2014/main" id="{64EF6624-3DC2-E340-A7D7-C639466C1FA7}"/>
-            </a:ext>
-          </a:extLst>
-        </p:cNvPr>
-        <p:cNvGrpSpPr/>
-        <p:nvPr/>
-      </p:nvGrpSpPr>
-      <p:grpSpPr>
-        <a:xfrm>
-          <a:off x="0" y="0"/>
-          <a:ext cx="0" cy="0"/>
-          <a:chOff x="0" y="0"/>
-          <a:chExt cx="0" cy="0"/>
-        </a:xfrm>
-      </p:grpSpPr>
-      <p:sp>
-        <p:nvSpPr>
-          <p:cNvPr id="2" name="Slide Image Placeholder 1">
-            <a:extLst>
-              <a:ext uri="{FF2B5EF4-FFF2-40B4-BE49-F238E27FC236}">
-                <a16:creationId xmlns:a16="http://schemas.microsoft.com/office/drawing/2014/main" id="{5DFEC2C2-C1D4-D0DC-94B6-24D973D64854}"/>
-              </a:ext>
-            </a:extLst>
-          </p:cNvPr>
-          <p:cNvSpPr>
-            <a:spLocks noGrp="1" noRot="1" noChangeAspect="1"/>
-          </p:cNvSpPr>
-          <p:nvPr>
-            <p:ph type="sldImg"/>
-          </p:nvPr>
-        </p:nvSpPr>
-        <p:spPr/>
-      </p:sp>
-      <p:sp>
-        <p:nvSpPr>
-          <p:cNvPr id="3" name="Notes Placeholder 2">
-            <a:extLst>
-              <a:ext uri="{FF2B5EF4-FFF2-40B4-BE49-F238E27FC236}">
-                <a16:creationId xmlns:a16="http://schemas.microsoft.com/office/drawing/2014/main" id="{DC98B1D0-935D-3637-C120-1CEF4FD6F489}"/>
-              </a:ext>
-            </a:extLst>
-          </p:cNvPr>
-          <p:cNvSpPr>
-            <a:spLocks noGrp="1"/>
-          </p:cNvSpPr>
-          <p:nvPr>
-            <p:ph type="body" idx="1"/>
-          </p:nvPr>
-        </p:nvSpPr>
-        <p:spPr/>
-        <p:txBody>
-          <a:bodyPr/>
-          <a:lstStyle/>
-          <a:p>
-            <a:endParaRPr lang="en-US"/>
-          </a:p>
-        </p:txBody>
-      </p:sp>
-      <p:sp>
-        <p:nvSpPr>
-          <p:cNvPr id="4" name="Slide Number Placeholder 3">
-            <a:extLst>
-              <a:ext uri="{FF2B5EF4-FFF2-40B4-BE49-F238E27FC236}">
-                <a16:creationId xmlns:a16="http://schemas.microsoft.com/office/drawing/2014/main" id="{5725798C-9EDE-4536-DFE5-61FB8626B747}"/>
-              </a:ext>
-            </a:extLst>
-          </p:cNvPr>
-          <p:cNvSpPr>
-            <a:spLocks noGrp="1"/>
-          </p:cNvSpPr>
-          <p:nvPr>
-            <p:ph type="sldNum" sz="quarter" idx="5"/>
-          </p:nvPr>
-        </p:nvSpPr>
-        <p:spPr/>
-        <p:txBody>
-          <a:bodyPr/>
-          <a:lstStyle/>
-          <a:p>
-            <a:fld id="{7EB8C794-77EE-4724-B493-2E0907BFA558}" type="slidenum">
-              <a:rPr lang="en-GB" smtClean="0"/>
-              <a:t>7</a:t>
-            </a:fld>
-            <a:endParaRPr lang="en-GB"/>
-          </a:p>
-        </p:txBody>
-      </p:sp>
-    </p:spTree>
-    <p:extLst>
-      <p:ext uri="{BB962C8B-B14F-4D97-AF65-F5344CB8AC3E}">
-        <p14:creationId xmlns:p14="http://schemas.microsoft.com/office/powerpoint/2010/main" val="2726051225"/>
-      </p:ext>
-    </p:extLst>
-  </p:cSld>
-  <p:clrMapOvr>
-    <a:masterClrMapping/>
-  </p:clrMapOvr>
-</p:notes>
-</file>
-
-<file path=ppt/notesSlides/notesSlide7.xml><?xml version="1.0" encoding="utf-8"?>
 <p:notes xmlns:a="http://schemas.openxmlformats.org/drawingml/2006/main" xmlns:r="http://schemas.openxmlformats.org/officeDocument/2006/relationships" xmlns:p="http://schemas.openxmlformats.org/presentationml/2006/main">
   <p:cSld>
     <p:spTree>
@@ -3111,115 +2211,7 @@
 </p:notes>
 </file>
 
-<file path=ppt/notesSlides/notesSlide8.xml><?xml version="1.0" encoding="utf-8"?>
-<p:notes xmlns:a="http://schemas.openxmlformats.org/drawingml/2006/main" xmlns:r="http://schemas.openxmlformats.org/officeDocument/2006/relationships" xmlns:p="http://schemas.openxmlformats.org/presentationml/2006/main">
-  <p:cSld>
-    <p:spTree>
-      <p:nvGrpSpPr>
-        <p:cNvPr id="1" name="">
-          <a:extLst>
-            <a:ext uri="{FF2B5EF4-FFF2-40B4-BE49-F238E27FC236}">
-              <a16:creationId xmlns:a16="http://schemas.microsoft.com/office/drawing/2014/main" id="{E6BCE4A0-0AA1-E271-625F-A7FD4E61A325}"/>
-            </a:ext>
-          </a:extLst>
-        </p:cNvPr>
-        <p:cNvGrpSpPr/>
-        <p:nvPr/>
-      </p:nvGrpSpPr>
-      <p:grpSpPr>
-        <a:xfrm>
-          <a:off x="0" y="0"/>
-          <a:ext cx="0" cy="0"/>
-          <a:chOff x="0" y="0"/>
-          <a:chExt cx="0" cy="0"/>
-        </a:xfrm>
-      </p:grpSpPr>
-      <p:sp>
-        <p:nvSpPr>
-          <p:cNvPr id="2" name="Slide Image Placeholder 1">
-            <a:extLst>
-              <a:ext uri="{FF2B5EF4-FFF2-40B4-BE49-F238E27FC236}">
-                <a16:creationId xmlns:a16="http://schemas.microsoft.com/office/drawing/2014/main" id="{4CAA5670-B381-EA14-A3A6-6B2CB7A78D40}"/>
-              </a:ext>
-            </a:extLst>
-          </p:cNvPr>
-          <p:cNvSpPr>
-            <a:spLocks noGrp="1" noRot="1" noChangeAspect="1"/>
-          </p:cNvSpPr>
-          <p:nvPr>
-            <p:ph type="sldImg"/>
-          </p:nvPr>
-        </p:nvSpPr>
-        <p:spPr/>
-      </p:sp>
-      <p:sp>
-        <p:nvSpPr>
-          <p:cNvPr id="3" name="Notes Placeholder 2">
-            <a:extLst>
-              <a:ext uri="{FF2B5EF4-FFF2-40B4-BE49-F238E27FC236}">
-                <a16:creationId xmlns:a16="http://schemas.microsoft.com/office/drawing/2014/main" id="{26D46F86-6651-C673-E87C-4E6377849872}"/>
-              </a:ext>
-            </a:extLst>
-          </p:cNvPr>
-          <p:cNvSpPr>
-            <a:spLocks noGrp="1"/>
-          </p:cNvSpPr>
-          <p:nvPr>
-            <p:ph type="body" idx="1"/>
-          </p:nvPr>
-        </p:nvSpPr>
-        <p:spPr/>
-        <p:txBody>
-          <a:bodyPr/>
-          <a:lstStyle/>
-          <a:p>
-            <a:endParaRPr lang="en-US"/>
-          </a:p>
-        </p:txBody>
-      </p:sp>
-      <p:sp>
-        <p:nvSpPr>
-          <p:cNvPr id="4" name="Slide Number Placeholder 3">
-            <a:extLst>
-              <a:ext uri="{FF2B5EF4-FFF2-40B4-BE49-F238E27FC236}">
-                <a16:creationId xmlns:a16="http://schemas.microsoft.com/office/drawing/2014/main" id="{9B454DCF-14DA-F2AA-CBAC-5EEC773FA70C}"/>
-              </a:ext>
-            </a:extLst>
-          </p:cNvPr>
-          <p:cNvSpPr>
-            <a:spLocks noGrp="1"/>
-          </p:cNvSpPr>
-          <p:nvPr>
-            <p:ph type="sldNum" sz="quarter" idx="5"/>
-          </p:nvPr>
-        </p:nvSpPr>
-        <p:spPr/>
-        <p:txBody>
-          <a:bodyPr/>
-          <a:lstStyle/>
-          <a:p>
-            <a:fld id="{7EB8C794-77EE-4724-B493-2E0907BFA558}" type="slidenum">
-              <a:rPr lang="en-GB" smtClean="0"/>
-              <a:t>9</a:t>
-            </a:fld>
-            <a:endParaRPr lang="en-GB"/>
-          </a:p>
-        </p:txBody>
-      </p:sp>
-    </p:spTree>
-    <p:extLst>
-      <p:ext uri="{BB962C8B-B14F-4D97-AF65-F5344CB8AC3E}">
-        <p14:creationId xmlns:p14="http://schemas.microsoft.com/office/powerpoint/2010/main" val="520218635"/>
-      </p:ext>
-    </p:extLst>
-  </p:cSld>
-  <p:clrMapOvr>
-    <a:masterClrMapping/>
-  </p:clrMapOvr>
-</p:notes>
-</file>
-
-<file path=ppt/notesSlides/notesSlide9.xml><?xml version="1.0" encoding="utf-8"?>
+<file path=ppt/notesSlides/notesSlide7.xml><?xml version="1.0" encoding="utf-8"?>
 <p:notes xmlns:a="http://schemas.openxmlformats.org/drawingml/2006/main" xmlns:r="http://schemas.openxmlformats.org/officeDocument/2006/relationships" xmlns:p="http://schemas.openxmlformats.org/presentationml/2006/main">
   <p:cSld>
     <p:spTree>
@@ -3308,7 +2300,7 @@
           <a:p>
             <a:fld id="{7EB8C794-77EE-4724-B493-2E0907BFA558}" type="slidenum">
               <a:rPr lang="en-GB" smtClean="0"/>
-              <a:t>10</a:t>
+              <a:t>9</a:t>
             </a:fld>
             <a:endParaRPr lang="en-GB"/>
           </a:p>
@@ -3318,6 +2310,452 @@
     <p:extLst>
       <p:ext uri="{BB962C8B-B14F-4D97-AF65-F5344CB8AC3E}">
         <p14:creationId xmlns:p14="http://schemas.microsoft.com/office/powerpoint/2010/main" val="4161228640"/>
+      </p:ext>
+    </p:extLst>
+  </p:cSld>
+  <p:clrMapOvr>
+    <a:masterClrMapping/>
+  </p:clrMapOvr>
+</p:notes>
+</file>
+
+<file path=ppt/notesSlides/notesSlide8.xml><?xml version="1.0" encoding="utf-8"?>
+<p:notes xmlns:a="http://schemas.openxmlformats.org/drawingml/2006/main" xmlns:r="http://schemas.openxmlformats.org/officeDocument/2006/relationships" xmlns:p="http://schemas.openxmlformats.org/presentationml/2006/main">
+  <p:cSld>
+    <p:spTree>
+      <p:nvGrpSpPr>
+        <p:cNvPr id="1" name="">
+          <a:extLst>
+            <a:ext uri="{FF2B5EF4-FFF2-40B4-BE49-F238E27FC236}">
+              <a16:creationId xmlns:a16="http://schemas.microsoft.com/office/drawing/2014/main" id="{E5E34A03-EDDC-496B-A252-C7FFBF6910FF}"/>
+            </a:ext>
+          </a:extLst>
+        </p:cNvPr>
+        <p:cNvGrpSpPr/>
+        <p:nvPr/>
+      </p:nvGrpSpPr>
+      <p:grpSpPr>
+        <a:xfrm>
+          <a:off x="0" y="0"/>
+          <a:ext cx="0" cy="0"/>
+          <a:chOff x="0" y="0"/>
+          <a:chExt cx="0" cy="0"/>
+        </a:xfrm>
+      </p:grpSpPr>
+      <p:sp>
+        <p:nvSpPr>
+          <p:cNvPr id="2" name="Slide Image Placeholder 1">
+            <a:extLst>
+              <a:ext uri="{FF2B5EF4-FFF2-40B4-BE49-F238E27FC236}">
+                <a16:creationId xmlns:a16="http://schemas.microsoft.com/office/drawing/2014/main" id="{48A9EF52-BEF5-A1DD-9400-B0F6CF9FCB38}"/>
+              </a:ext>
+            </a:extLst>
+          </p:cNvPr>
+          <p:cNvSpPr>
+            <a:spLocks noGrp="1" noRot="1" noChangeAspect="1"/>
+          </p:cNvSpPr>
+          <p:nvPr>
+            <p:ph type="sldImg"/>
+          </p:nvPr>
+        </p:nvSpPr>
+        <p:spPr/>
+      </p:sp>
+      <p:sp>
+        <p:nvSpPr>
+          <p:cNvPr id="3" name="Notes Placeholder 2">
+            <a:extLst>
+              <a:ext uri="{FF2B5EF4-FFF2-40B4-BE49-F238E27FC236}">
+                <a16:creationId xmlns:a16="http://schemas.microsoft.com/office/drawing/2014/main" id="{9CD63604-03EE-C33D-885B-D60B1D085275}"/>
+              </a:ext>
+            </a:extLst>
+          </p:cNvPr>
+          <p:cNvSpPr>
+            <a:spLocks noGrp="1"/>
+          </p:cNvSpPr>
+          <p:nvPr>
+            <p:ph type="body" idx="1"/>
+          </p:nvPr>
+        </p:nvSpPr>
+        <p:spPr/>
+        <p:txBody>
+          <a:bodyPr/>
+          <a:lstStyle/>
+          <a:p>
+            <a:r>
+              <a:rPr lang="en-US" dirty="0">
+                <a:ea typeface="Calibri"/>
+                <a:cs typeface="Calibri"/>
+              </a:rPr>
+              <a:t>How often do we use tests in our projects?</a:t>
+            </a:r>
+          </a:p>
+          <a:p>
+            <a:r>
+              <a:rPr lang="en-US">
+                <a:ea typeface="Calibri"/>
+                <a:cs typeface="Calibri"/>
+              </a:rPr>
+              <a:t>It depends on:</a:t>
+            </a:r>
+          </a:p>
+          <a:p>
+            <a:pPr marL="171450" indent="-171450">
+              <a:buFont typeface="Calibri"/>
+              <a:buChar char="-"/>
+            </a:pPr>
+            <a:r>
+              <a:rPr lang="en-US" dirty="0">
+                <a:ea typeface="Calibri"/>
+                <a:cs typeface="Calibri"/>
+              </a:rPr>
+              <a:t>Budget</a:t>
+            </a:r>
+          </a:p>
+          <a:p>
+            <a:pPr marL="171450" indent="-171450">
+              <a:buFont typeface="Calibri"/>
+              <a:buChar char="-"/>
+            </a:pPr>
+            <a:r>
+              <a:rPr lang="en-US" dirty="0">
+                <a:ea typeface="Calibri"/>
+                <a:cs typeface="Calibri"/>
+              </a:rPr>
+              <a:t>Timing</a:t>
+            </a:r>
+          </a:p>
+          <a:p>
+            <a:pPr marL="171450" indent="-171450">
+              <a:buFont typeface="Calibri"/>
+              <a:buChar char="-"/>
+            </a:pPr>
+            <a:r>
+              <a:rPr lang="en-US" dirty="0">
+                <a:ea typeface="Calibri"/>
+                <a:cs typeface="Calibri"/>
+              </a:rPr>
+              <a:t>Customers says it's not needed</a:t>
+            </a:r>
+          </a:p>
+          <a:p>
+            <a:endParaRPr lang="en-US" dirty="0">
+              <a:ea typeface="Calibri"/>
+              <a:cs typeface="Calibri"/>
+            </a:endParaRPr>
+          </a:p>
+          <a:p>
+            <a:r>
+              <a:rPr lang="en-US" dirty="0">
+                <a:ea typeface="Calibri"/>
+                <a:cs typeface="Calibri"/>
+              </a:rPr>
+              <a:t>Giveaways</a:t>
+            </a:r>
+          </a:p>
+          <a:p>
+            <a:pPr marL="171450" indent="-171450">
+              <a:buFont typeface="Calibri"/>
+              <a:buChar char="-"/>
+            </a:pPr>
+            <a:r>
+              <a:rPr lang="en-US" dirty="0">
+                <a:ea typeface="Calibri"/>
+                <a:cs typeface="Calibri"/>
+              </a:rPr>
+              <a:t>Unit tests saves can save our life and are responsible to have an expected behavior of your application over multiple deployments and changes.</a:t>
+            </a:r>
+          </a:p>
+          <a:p>
+            <a:pPr marL="171450" indent="-171450">
+              <a:buFont typeface="Calibri"/>
+              <a:buChar char="-"/>
+            </a:pPr>
+            <a:r>
+              <a:rPr lang="en-US" dirty="0">
+                <a:ea typeface="Calibri"/>
+                <a:cs typeface="Calibri"/>
+              </a:rPr>
+              <a:t>Who writes the code should not test it but leave it to another person of the team</a:t>
+            </a:r>
+          </a:p>
+          <a:p>
+            <a:pPr marL="171450" indent="-171450">
+              <a:buFont typeface="Calibri"/>
+              <a:buChar char="-"/>
+            </a:pPr>
+            <a:endParaRPr lang="en-US" dirty="0">
+              <a:ea typeface="Calibri"/>
+              <a:cs typeface="Calibri"/>
+            </a:endParaRPr>
+          </a:p>
+          <a:p>
+            <a:pPr marL="171450" indent="-171450">
+              <a:buFont typeface="Calibri"/>
+              <a:buChar char="-"/>
+            </a:pPr>
+            <a:endParaRPr lang="en-US" dirty="0">
+              <a:ea typeface="Calibri"/>
+              <a:cs typeface="Calibri"/>
+            </a:endParaRPr>
+          </a:p>
+        </p:txBody>
+      </p:sp>
+      <p:sp>
+        <p:nvSpPr>
+          <p:cNvPr id="4" name="Slide Number Placeholder 3">
+            <a:extLst>
+              <a:ext uri="{FF2B5EF4-FFF2-40B4-BE49-F238E27FC236}">
+                <a16:creationId xmlns:a16="http://schemas.microsoft.com/office/drawing/2014/main" id="{C242478F-627E-D87B-5821-E7FA3AAFEC44}"/>
+              </a:ext>
+            </a:extLst>
+          </p:cNvPr>
+          <p:cNvSpPr>
+            <a:spLocks noGrp="1"/>
+          </p:cNvSpPr>
+          <p:nvPr>
+            <p:ph type="sldNum" sz="quarter" idx="5"/>
+          </p:nvPr>
+        </p:nvSpPr>
+        <p:spPr/>
+        <p:txBody>
+          <a:bodyPr/>
+          <a:lstStyle/>
+          <a:p>
+            <a:fld id="{7EB8C794-77EE-4724-B493-2E0907BFA558}" type="slidenum">
+              <a:rPr lang="en-GB" smtClean="0"/>
+              <a:t>10</a:t>
+            </a:fld>
+            <a:endParaRPr lang="en-GB"/>
+          </a:p>
+        </p:txBody>
+      </p:sp>
+    </p:spTree>
+    <p:extLst>
+      <p:ext uri="{BB962C8B-B14F-4D97-AF65-F5344CB8AC3E}">
+        <p14:creationId xmlns:p14="http://schemas.microsoft.com/office/powerpoint/2010/main" val="2612603715"/>
+      </p:ext>
+    </p:extLst>
+  </p:cSld>
+  <p:clrMapOvr>
+    <a:masterClrMapping/>
+  </p:clrMapOvr>
+</p:notes>
+</file>
+
+<file path=ppt/notesSlides/notesSlide9.xml><?xml version="1.0" encoding="utf-8"?>
+<p:notes xmlns:a="http://schemas.openxmlformats.org/drawingml/2006/main" xmlns:r="http://schemas.openxmlformats.org/officeDocument/2006/relationships" xmlns:p="http://schemas.openxmlformats.org/presentationml/2006/main">
+  <p:cSld>
+    <p:spTree>
+      <p:nvGrpSpPr>
+        <p:cNvPr id="1" name="">
+          <a:extLst>
+            <a:ext uri="{FF2B5EF4-FFF2-40B4-BE49-F238E27FC236}">
+              <a16:creationId xmlns:a16="http://schemas.microsoft.com/office/drawing/2014/main" id="{2D45DC49-A269-D24C-E4C8-75E5BCE198F7}"/>
+            </a:ext>
+          </a:extLst>
+        </p:cNvPr>
+        <p:cNvGrpSpPr/>
+        <p:nvPr/>
+      </p:nvGrpSpPr>
+      <p:grpSpPr>
+        <a:xfrm>
+          <a:off x="0" y="0"/>
+          <a:ext cx="0" cy="0"/>
+          <a:chOff x="0" y="0"/>
+          <a:chExt cx="0" cy="0"/>
+        </a:xfrm>
+      </p:grpSpPr>
+      <p:sp>
+        <p:nvSpPr>
+          <p:cNvPr id="2" name="Slide Image Placeholder 1">
+            <a:extLst>
+              <a:ext uri="{FF2B5EF4-FFF2-40B4-BE49-F238E27FC236}">
+                <a16:creationId xmlns:a16="http://schemas.microsoft.com/office/drawing/2014/main" id="{722FAF7C-28B0-293F-58BE-68267837BDBE}"/>
+              </a:ext>
+            </a:extLst>
+          </p:cNvPr>
+          <p:cNvSpPr>
+            <a:spLocks noGrp="1" noRot="1" noChangeAspect="1"/>
+          </p:cNvSpPr>
+          <p:nvPr>
+            <p:ph type="sldImg"/>
+          </p:nvPr>
+        </p:nvSpPr>
+        <p:spPr/>
+      </p:sp>
+      <p:sp>
+        <p:nvSpPr>
+          <p:cNvPr id="3" name="Notes Placeholder 2">
+            <a:extLst>
+              <a:ext uri="{FF2B5EF4-FFF2-40B4-BE49-F238E27FC236}">
+                <a16:creationId xmlns:a16="http://schemas.microsoft.com/office/drawing/2014/main" id="{66A4D9B9-AA9D-7422-0FFE-2998DA32119B}"/>
+              </a:ext>
+            </a:extLst>
+          </p:cNvPr>
+          <p:cNvSpPr>
+            <a:spLocks noGrp="1"/>
+          </p:cNvSpPr>
+          <p:nvPr>
+            <p:ph type="body" idx="1"/>
+          </p:nvPr>
+        </p:nvSpPr>
+        <p:spPr/>
+        <p:txBody>
+          <a:bodyPr/>
+          <a:lstStyle/>
+          <a:p>
+            <a:r>
+              <a:rPr lang="en-US" dirty="0">
+                <a:ea typeface="Calibri"/>
+                <a:cs typeface="Calibri"/>
+              </a:rPr>
+              <a:t>How often do we use tests in our projects?</a:t>
+            </a:r>
+          </a:p>
+          <a:p>
+            <a:r>
+              <a:rPr lang="en-US">
+                <a:ea typeface="Calibri"/>
+                <a:cs typeface="Calibri"/>
+              </a:rPr>
+              <a:t>It depends on:</a:t>
+            </a:r>
+          </a:p>
+          <a:p>
+            <a:pPr marL="171450" indent="-171450">
+              <a:buFont typeface="Calibri"/>
+              <a:buChar char="-"/>
+            </a:pPr>
+            <a:r>
+              <a:rPr lang="en-US" dirty="0">
+                <a:ea typeface="Calibri"/>
+                <a:cs typeface="Calibri"/>
+              </a:rPr>
+              <a:t>Budget</a:t>
+            </a:r>
+          </a:p>
+          <a:p>
+            <a:pPr marL="171450" indent="-171450">
+              <a:buFont typeface="Calibri"/>
+              <a:buChar char="-"/>
+            </a:pPr>
+            <a:r>
+              <a:rPr lang="en-US" dirty="0">
+                <a:ea typeface="Calibri"/>
+                <a:cs typeface="Calibri"/>
+              </a:rPr>
+              <a:t>Timing</a:t>
+            </a:r>
+          </a:p>
+          <a:p>
+            <a:pPr marL="171450" indent="-171450">
+              <a:buFont typeface="Calibri"/>
+              <a:buChar char="-"/>
+            </a:pPr>
+            <a:r>
+              <a:rPr lang="en-US" dirty="0">
+                <a:ea typeface="Calibri"/>
+                <a:cs typeface="Calibri"/>
+              </a:rPr>
+              <a:t>Customers says it's not needed</a:t>
+            </a:r>
+          </a:p>
+          <a:p>
+            <a:endParaRPr lang="en-US" dirty="0">
+              <a:ea typeface="Calibri"/>
+              <a:cs typeface="Calibri"/>
+            </a:endParaRPr>
+          </a:p>
+          <a:p>
+            <a:r>
+              <a:rPr lang="en-US" dirty="0">
+                <a:ea typeface="Calibri"/>
+                <a:cs typeface="Calibri"/>
+              </a:rPr>
+              <a:t>Giveaways</a:t>
+            </a:r>
+          </a:p>
+          <a:p>
+            <a:pPr marL="171450" indent="-171450">
+              <a:buFont typeface="Calibri"/>
+              <a:buChar char="-"/>
+            </a:pPr>
+            <a:r>
+              <a:rPr lang="en-US" dirty="0">
+                <a:ea typeface="Calibri"/>
+                <a:cs typeface="Calibri"/>
+              </a:rPr>
+              <a:t>Unit tests saves can save our life and are responsible to have an expected behavior of your application over multiple deployments and changes.</a:t>
+            </a:r>
+          </a:p>
+          <a:p>
+            <a:pPr marL="171450" indent="-171450">
+              <a:buFont typeface="Calibri"/>
+              <a:buChar char="-"/>
+            </a:pPr>
+            <a:r>
+              <a:rPr lang="en-US" dirty="0">
+                <a:ea typeface="Calibri"/>
+                <a:cs typeface="Calibri"/>
+              </a:rPr>
+              <a:t>Who writes the code should not test it but leave it to another person of the team</a:t>
+            </a:r>
+          </a:p>
+          <a:p>
+            <a:pPr marL="171450" indent="-171450">
+              <a:buFont typeface="Calibri"/>
+              <a:buChar char="-"/>
+            </a:pPr>
+            <a:endParaRPr lang="en-US" dirty="0">
+              <a:ea typeface="Calibri"/>
+              <a:cs typeface="Calibri"/>
+            </a:endParaRPr>
+          </a:p>
+          <a:p>
+            <a:pPr marL="171450" indent="-171450">
+              <a:buFont typeface="Calibri"/>
+              <a:buChar char="-"/>
+            </a:pPr>
+            <a:endParaRPr lang="en-US" dirty="0">
+              <a:ea typeface="Calibri"/>
+              <a:cs typeface="Calibri"/>
+            </a:endParaRPr>
+          </a:p>
+        </p:txBody>
+      </p:sp>
+      <p:sp>
+        <p:nvSpPr>
+          <p:cNvPr id="4" name="Slide Number Placeholder 3">
+            <a:extLst>
+              <a:ext uri="{FF2B5EF4-FFF2-40B4-BE49-F238E27FC236}">
+                <a16:creationId xmlns:a16="http://schemas.microsoft.com/office/drawing/2014/main" id="{0D40BFFB-821F-4B9A-38C5-7DC704AF23EB}"/>
+              </a:ext>
+            </a:extLst>
+          </p:cNvPr>
+          <p:cNvSpPr>
+            <a:spLocks noGrp="1"/>
+          </p:cNvSpPr>
+          <p:nvPr>
+            <p:ph type="sldNum" sz="quarter" idx="5"/>
+          </p:nvPr>
+        </p:nvSpPr>
+        <p:spPr/>
+        <p:txBody>
+          <a:bodyPr/>
+          <a:lstStyle/>
+          <a:p>
+            <a:fld id="{7EB8C794-77EE-4724-B493-2E0907BFA558}" type="slidenum">
+              <a:rPr lang="en-GB" smtClean="0"/>
+              <a:t>11</a:t>
+            </a:fld>
+            <a:endParaRPr lang="en-GB"/>
+          </a:p>
+        </p:txBody>
+      </p:sp>
+    </p:spTree>
+    <p:extLst>
+      <p:ext uri="{BB962C8B-B14F-4D97-AF65-F5344CB8AC3E}">
+        <p14:creationId xmlns:p14="http://schemas.microsoft.com/office/powerpoint/2010/main" val="1301111360"/>
       </p:ext>
     </p:extLst>
   </p:cSld>
@@ -7165,648 +6603,6 @@
         <p:cNvPr id="1" name="">
           <a:extLst>
             <a:ext uri="{FF2B5EF4-FFF2-40B4-BE49-F238E27FC236}">
-              <a16:creationId xmlns:a16="http://schemas.microsoft.com/office/drawing/2014/main" id="{CE6AA263-EDC0-82B9-0839-92AF21ACE1CD}"/>
-            </a:ext>
-          </a:extLst>
-        </p:cNvPr>
-        <p:cNvGrpSpPr/>
-        <p:nvPr/>
-      </p:nvGrpSpPr>
-      <p:grpSpPr>
-        <a:xfrm>
-          <a:off x="0" y="0"/>
-          <a:ext cx="0" cy="0"/>
-          <a:chOff x="0" y="0"/>
-          <a:chExt cx="0" cy="0"/>
-        </a:xfrm>
-      </p:grpSpPr>
-      <p:sp>
-        <p:nvSpPr>
-          <p:cNvPr id="4" name="Text Placeholder 3">
-            <a:extLst>
-              <a:ext uri="{FF2B5EF4-FFF2-40B4-BE49-F238E27FC236}">
-                <a16:creationId xmlns:a16="http://schemas.microsoft.com/office/drawing/2014/main" id="{0CBA97D0-9053-786F-6374-AD269EB13774}"/>
-              </a:ext>
-            </a:extLst>
-          </p:cNvPr>
-          <p:cNvSpPr>
-            <a:spLocks noGrp="1"/>
-          </p:cNvSpPr>
-          <p:nvPr>
-            <p:ph type="body" sz="quarter" idx="10"/>
-          </p:nvPr>
-        </p:nvSpPr>
-        <p:spPr/>
-        <p:txBody>
-          <a:bodyPr lIns="91440" tIns="45720" rIns="91440" bIns="45720" anchor="t"/>
-          <a:lstStyle/>
-          <a:p>
-            <a:r>
-              <a:rPr lang="it-IT" dirty="0">
-                <a:latin typeface="Arial"/>
-                <a:cs typeface="Arial"/>
-              </a:rPr>
-              <a:t>e2e</a:t>
-            </a:r>
-            <a:r>
-              <a:rPr lang="en-IT" dirty="0">
-                <a:latin typeface="Arial"/>
-                <a:cs typeface="Arial"/>
-              </a:rPr>
-              <a:t> testing</a:t>
-            </a:r>
-            <a:endParaRPr lang="en-US" dirty="0"/>
-          </a:p>
-        </p:txBody>
-      </p:sp>
-      <p:sp>
-        <p:nvSpPr>
-          <p:cNvPr id="6" name="Text Placeholder 3">
-            <a:extLst>
-              <a:ext uri="{FF2B5EF4-FFF2-40B4-BE49-F238E27FC236}">
-                <a16:creationId xmlns:a16="http://schemas.microsoft.com/office/drawing/2014/main" id="{BDFF9A42-A75A-359A-8534-541E28FE0BB2}"/>
-              </a:ext>
-            </a:extLst>
-          </p:cNvPr>
-          <p:cNvSpPr txBox="1">
-            <a:spLocks/>
-          </p:cNvSpPr>
-          <p:nvPr/>
-        </p:nvSpPr>
-        <p:spPr>
-          <a:xfrm>
-            <a:off x="6209198" y="4788827"/>
-            <a:ext cx="5445392" cy="849973"/>
-          </a:xfrm>
-          <a:prstGeom prst="rect">
-            <a:avLst/>
-          </a:prstGeom>
-        </p:spPr>
-        <p:txBody>
-          <a:bodyPr lIns="91440" tIns="45720" rIns="91440" bIns="45720" anchor="t"/>
-          <a:lstStyle>
-            <a:lvl1pPr marL="0" indent="0" algn="l" defTabSz="914400" rtl="0" eaLnBrk="1" latinLnBrk="0" hangingPunct="1">
-              <a:lnSpc>
-                <a:spcPct val="90000"/>
-              </a:lnSpc>
-              <a:spcBef>
-                <a:spcPts val="1000"/>
-              </a:spcBef>
-              <a:buFont typeface="Arial"/>
-              <a:buNone/>
-              <a:defRPr sz="4800" b="1" kern="1200">
-                <a:solidFill>
-                  <a:srgbClr val="00C700"/>
-                </a:solidFill>
-                <a:latin typeface="Arial" panose="020B0604020202020204" pitchFamily="34" charset="0"/>
-                <a:ea typeface="+mn-ea"/>
-                <a:cs typeface="Arial" panose="020B0604020202020204" pitchFamily="34" charset="0"/>
-              </a:defRPr>
-            </a:lvl1pPr>
-            <a:lvl2pPr marL="685800" indent="-228600" algn="l" defTabSz="914400" rtl="0" eaLnBrk="1" latinLnBrk="0" hangingPunct="1">
-              <a:lnSpc>
-                <a:spcPct val="90000"/>
-              </a:lnSpc>
-              <a:spcBef>
-                <a:spcPts val="500"/>
-              </a:spcBef>
-              <a:buFont typeface="Arial"/>
-              <a:buChar char="•"/>
-              <a:defRPr sz="2400" kern="1200">
-                <a:solidFill>
-                  <a:srgbClr val="00E2FF"/>
-                </a:solidFill>
-                <a:latin typeface="+mn-lt"/>
-                <a:ea typeface="+mn-ea"/>
-                <a:cs typeface="+mn-cs"/>
-              </a:defRPr>
-            </a:lvl2pPr>
-            <a:lvl3pPr marL="1143000" indent="-228600" algn="l" defTabSz="914400" rtl="0" eaLnBrk="1" latinLnBrk="0" hangingPunct="1">
-              <a:lnSpc>
-                <a:spcPct val="90000"/>
-              </a:lnSpc>
-              <a:spcBef>
-                <a:spcPts val="500"/>
-              </a:spcBef>
-              <a:buFont typeface="Arial"/>
-              <a:buChar char="•"/>
-              <a:defRPr sz="2000" kern="1200">
-                <a:solidFill>
-                  <a:srgbClr val="00E2FF"/>
-                </a:solidFill>
-                <a:latin typeface="+mn-lt"/>
-                <a:ea typeface="+mn-ea"/>
-                <a:cs typeface="+mn-cs"/>
-              </a:defRPr>
-            </a:lvl3pPr>
-            <a:lvl4pPr marL="1600200" indent="-228600" algn="l" defTabSz="914400" rtl="0" eaLnBrk="1" latinLnBrk="0" hangingPunct="1">
-              <a:lnSpc>
-                <a:spcPct val="90000"/>
-              </a:lnSpc>
-              <a:spcBef>
-                <a:spcPts val="500"/>
-              </a:spcBef>
-              <a:buFont typeface="Arial"/>
-              <a:buChar char="•"/>
-              <a:defRPr sz="1800" kern="1200">
-                <a:solidFill>
-                  <a:srgbClr val="00E2FF"/>
-                </a:solidFill>
-                <a:latin typeface="+mn-lt"/>
-                <a:ea typeface="+mn-ea"/>
-                <a:cs typeface="+mn-cs"/>
-              </a:defRPr>
-            </a:lvl4pPr>
-            <a:lvl5pPr marL="2057400" indent="-228600" algn="l" defTabSz="914400" rtl="0" eaLnBrk="1" latinLnBrk="0" hangingPunct="1">
-              <a:lnSpc>
-                <a:spcPct val="90000"/>
-              </a:lnSpc>
-              <a:spcBef>
-                <a:spcPts val="500"/>
-              </a:spcBef>
-              <a:buFont typeface="Arial"/>
-              <a:buChar char="•"/>
-              <a:defRPr sz="1800" kern="1200">
-                <a:solidFill>
-                  <a:srgbClr val="00E2FF"/>
-                </a:solidFill>
-                <a:latin typeface="+mn-lt"/>
-                <a:ea typeface="+mn-ea"/>
-                <a:cs typeface="+mn-cs"/>
-              </a:defRPr>
-            </a:lvl5pPr>
-            <a:lvl6pPr marL="2514600" indent="-228600" algn="l" defTabSz="914400" rtl="0" eaLnBrk="1" latinLnBrk="0" hangingPunct="1">
-              <a:lnSpc>
-                <a:spcPct val="90000"/>
-              </a:lnSpc>
-              <a:spcBef>
-                <a:spcPts val="500"/>
-              </a:spcBef>
-              <a:buFont typeface="Arial"/>
-              <a:buChar char="•"/>
-              <a:defRPr sz="1800" kern="1200">
-                <a:solidFill>
-                  <a:schemeClr val="tx1"/>
-                </a:solidFill>
-                <a:latin typeface="+mn-lt"/>
-                <a:ea typeface="+mn-ea"/>
-                <a:cs typeface="+mn-cs"/>
-              </a:defRPr>
-            </a:lvl6pPr>
-            <a:lvl7pPr marL="2971800" indent="-228600" algn="l" defTabSz="914400" rtl="0" eaLnBrk="1" latinLnBrk="0" hangingPunct="1">
-              <a:lnSpc>
-                <a:spcPct val="90000"/>
-              </a:lnSpc>
-              <a:spcBef>
-                <a:spcPts val="500"/>
-              </a:spcBef>
-              <a:buFont typeface="Arial"/>
-              <a:buChar char="•"/>
-              <a:defRPr sz="1800" kern="1200">
-                <a:solidFill>
-                  <a:schemeClr val="tx1"/>
-                </a:solidFill>
-                <a:latin typeface="+mn-lt"/>
-                <a:ea typeface="+mn-ea"/>
-                <a:cs typeface="+mn-cs"/>
-              </a:defRPr>
-            </a:lvl7pPr>
-            <a:lvl8pPr marL="3429000" indent="-228600" algn="l" defTabSz="914400" rtl="0" eaLnBrk="1" latinLnBrk="0" hangingPunct="1">
-              <a:lnSpc>
-                <a:spcPct val="90000"/>
-              </a:lnSpc>
-              <a:spcBef>
-                <a:spcPts val="500"/>
-              </a:spcBef>
-              <a:buFont typeface="Arial"/>
-              <a:buChar char="•"/>
-              <a:defRPr sz="1800" kern="1200">
-                <a:solidFill>
-                  <a:schemeClr val="tx1"/>
-                </a:solidFill>
-                <a:latin typeface="+mn-lt"/>
-                <a:ea typeface="+mn-ea"/>
-                <a:cs typeface="+mn-cs"/>
-              </a:defRPr>
-            </a:lvl8pPr>
-            <a:lvl9pPr marL="3886200" indent="-228600" algn="l" defTabSz="914400" rtl="0" eaLnBrk="1" latinLnBrk="0" hangingPunct="1">
-              <a:lnSpc>
-                <a:spcPct val="90000"/>
-              </a:lnSpc>
-              <a:spcBef>
-                <a:spcPts val="500"/>
-              </a:spcBef>
-              <a:buFont typeface="Arial"/>
-              <a:buChar char="•"/>
-              <a:defRPr sz="1800" kern="1200">
-                <a:solidFill>
-                  <a:schemeClr val="tx1"/>
-                </a:solidFill>
-                <a:latin typeface="+mn-lt"/>
-                <a:ea typeface="+mn-ea"/>
-                <a:cs typeface="+mn-cs"/>
-              </a:defRPr>
-            </a:lvl9pPr>
-          </a:lstStyle>
-          <a:p>
-            <a:endParaRPr lang="en-US" dirty="0"/>
-          </a:p>
-        </p:txBody>
-      </p:sp>
-    </p:spTree>
-    <p:extLst>
-      <p:ext uri="{BB962C8B-B14F-4D97-AF65-F5344CB8AC3E}">
-        <p14:creationId xmlns:p14="http://schemas.microsoft.com/office/powerpoint/2010/main" val="1979839893"/>
-      </p:ext>
-    </p:extLst>
-  </p:cSld>
-  <p:clrMapOvr>
-    <a:masterClrMapping/>
-  </p:clrMapOvr>
-</p:sld>
-</file>
-
-<file path=ppt/slides/slide11.xml><?xml version="1.0" encoding="utf-8"?>
-<p:sld xmlns:a="http://schemas.openxmlformats.org/drawingml/2006/main" xmlns:r="http://schemas.openxmlformats.org/officeDocument/2006/relationships" xmlns:p="http://schemas.openxmlformats.org/presentationml/2006/main">
-  <p:cSld>
-    <p:bg>
-      <p:bgPr>
-        <a:blipFill dpi="0" rotWithShape="1">
-          <a:blip r:embed="rId3" cstate="print">
-            <a:lum/>
-            <a:extLst>
-              <a:ext uri="{28A0092B-C50C-407E-A947-70E740481C1C}">
-                <a14:useLocalDpi xmlns:a14="http://schemas.microsoft.com/office/drawing/2010/main"/>
-              </a:ext>
-            </a:extLst>
-          </a:blip>
-          <a:srcRect/>
-          <a:stretch>
-            <a:fillRect/>
-          </a:stretch>
-        </a:blipFill>
-        <a:effectLst/>
-      </p:bgPr>
-    </p:bg>
-    <p:spTree>
-      <p:nvGrpSpPr>
-        <p:cNvPr id="1" name="">
-          <a:extLst>
-            <a:ext uri="{FF2B5EF4-FFF2-40B4-BE49-F238E27FC236}">
-              <a16:creationId xmlns:a16="http://schemas.microsoft.com/office/drawing/2014/main" id="{5805A5E5-D3EC-44E9-752C-D3A5E830A955}"/>
-            </a:ext>
-          </a:extLst>
-        </p:cNvPr>
-        <p:cNvGrpSpPr/>
-        <p:nvPr/>
-      </p:nvGrpSpPr>
-      <p:grpSpPr>
-        <a:xfrm>
-          <a:off x="0" y="0"/>
-          <a:ext cx="0" cy="0"/>
-          <a:chOff x="0" y="0"/>
-          <a:chExt cx="0" cy="0"/>
-        </a:xfrm>
-      </p:grpSpPr>
-      <p:sp>
-        <p:nvSpPr>
-          <p:cNvPr id="4" name="Text Placeholder 3">
-            <a:extLst>
-              <a:ext uri="{FF2B5EF4-FFF2-40B4-BE49-F238E27FC236}">
-                <a16:creationId xmlns:a16="http://schemas.microsoft.com/office/drawing/2014/main" id="{6CE9F7C7-5705-43AF-5BDB-A32A450340BE}"/>
-              </a:ext>
-            </a:extLst>
-          </p:cNvPr>
-          <p:cNvSpPr>
-            <a:spLocks noGrp="1"/>
-          </p:cNvSpPr>
-          <p:nvPr>
-            <p:ph type="body" sz="quarter" idx="10"/>
-          </p:nvPr>
-        </p:nvSpPr>
-        <p:spPr/>
-        <p:txBody>
-          <a:bodyPr lIns="91440" tIns="45720" rIns="91440" bIns="45720" anchor="t"/>
-          <a:lstStyle/>
-          <a:p>
-            <a:r>
-              <a:rPr lang="it-IT" dirty="0">
-                <a:latin typeface="Arial"/>
-                <a:cs typeface="Arial"/>
-              </a:rPr>
-              <a:t>e2e</a:t>
-            </a:r>
-            <a:r>
-              <a:rPr lang="en-IT" dirty="0">
-                <a:latin typeface="Arial"/>
-                <a:cs typeface="Arial"/>
-              </a:rPr>
-              <a:t> testing</a:t>
-            </a:r>
-            <a:endParaRPr lang="en-US" dirty="0"/>
-          </a:p>
-        </p:txBody>
-      </p:sp>
-      <p:sp>
-        <p:nvSpPr>
-          <p:cNvPr id="6" name="Text Placeholder 3">
-            <a:extLst>
-              <a:ext uri="{FF2B5EF4-FFF2-40B4-BE49-F238E27FC236}">
-                <a16:creationId xmlns:a16="http://schemas.microsoft.com/office/drawing/2014/main" id="{74ABDC1B-4C09-B487-189D-2D3D6D1551D4}"/>
-              </a:ext>
-            </a:extLst>
-          </p:cNvPr>
-          <p:cNvSpPr txBox="1">
-            <a:spLocks/>
-          </p:cNvSpPr>
-          <p:nvPr/>
-        </p:nvSpPr>
-        <p:spPr>
-          <a:xfrm>
-            <a:off x="6209198" y="4788827"/>
-            <a:ext cx="5445392" cy="849973"/>
-          </a:xfrm>
-          <a:prstGeom prst="rect">
-            <a:avLst/>
-          </a:prstGeom>
-        </p:spPr>
-        <p:txBody>
-          <a:bodyPr lIns="91440" tIns="45720" rIns="91440" bIns="45720" anchor="t"/>
-          <a:lstStyle>
-            <a:lvl1pPr marL="0" indent="0" algn="l" defTabSz="914400" rtl="0" eaLnBrk="1" latinLnBrk="0" hangingPunct="1">
-              <a:lnSpc>
-                <a:spcPct val="90000"/>
-              </a:lnSpc>
-              <a:spcBef>
-                <a:spcPts val="1000"/>
-              </a:spcBef>
-              <a:buFont typeface="Arial"/>
-              <a:buNone/>
-              <a:defRPr sz="4800" b="1" kern="1200">
-                <a:solidFill>
-                  <a:srgbClr val="00C700"/>
-                </a:solidFill>
-                <a:latin typeface="Arial" panose="020B0604020202020204" pitchFamily="34" charset="0"/>
-                <a:ea typeface="+mn-ea"/>
-                <a:cs typeface="Arial" panose="020B0604020202020204" pitchFamily="34" charset="0"/>
-              </a:defRPr>
-            </a:lvl1pPr>
-            <a:lvl2pPr marL="685800" indent="-228600" algn="l" defTabSz="914400" rtl="0" eaLnBrk="1" latinLnBrk="0" hangingPunct="1">
-              <a:lnSpc>
-                <a:spcPct val="90000"/>
-              </a:lnSpc>
-              <a:spcBef>
-                <a:spcPts val="500"/>
-              </a:spcBef>
-              <a:buFont typeface="Arial"/>
-              <a:buChar char="•"/>
-              <a:defRPr sz="2400" kern="1200">
-                <a:solidFill>
-                  <a:srgbClr val="00E2FF"/>
-                </a:solidFill>
-                <a:latin typeface="+mn-lt"/>
-                <a:ea typeface="+mn-ea"/>
-                <a:cs typeface="+mn-cs"/>
-              </a:defRPr>
-            </a:lvl2pPr>
-            <a:lvl3pPr marL="1143000" indent="-228600" algn="l" defTabSz="914400" rtl="0" eaLnBrk="1" latinLnBrk="0" hangingPunct="1">
-              <a:lnSpc>
-                <a:spcPct val="90000"/>
-              </a:lnSpc>
-              <a:spcBef>
-                <a:spcPts val="500"/>
-              </a:spcBef>
-              <a:buFont typeface="Arial"/>
-              <a:buChar char="•"/>
-              <a:defRPr sz="2000" kern="1200">
-                <a:solidFill>
-                  <a:srgbClr val="00E2FF"/>
-                </a:solidFill>
-                <a:latin typeface="+mn-lt"/>
-                <a:ea typeface="+mn-ea"/>
-                <a:cs typeface="+mn-cs"/>
-              </a:defRPr>
-            </a:lvl3pPr>
-            <a:lvl4pPr marL="1600200" indent="-228600" algn="l" defTabSz="914400" rtl="0" eaLnBrk="1" latinLnBrk="0" hangingPunct="1">
-              <a:lnSpc>
-                <a:spcPct val="90000"/>
-              </a:lnSpc>
-              <a:spcBef>
-                <a:spcPts val="500"/>
-              </a:spcBef>
-              <a:buFont typeface="Arial"/>
-              <a:buChar char="•"/>
-              <a:defRPr sz="1800" kern="1200">
-                <a:solidFill>
-                  <a:srgbClr val="00E2FF"/>
-                </a:solidFill>
-                <a:latin typeface="+mn-lt"/>
-                <a:ea typeface="+mn-ea"/>
-                <a:cs typeface="+mn-cs"/>
-              </a:defRPr>
-            </a:lvl4pPr>
-            <a:lvl5pPr marL="2057400" indent="-228600" algn="l" defTabSz="914400" rtl="0" eaLnBrk="1" latinLnBrk="0" hangingPunct="1">
-              <a:lnSpc>
-                <a:spcPct val="90000"/>
-              </a:lnSpc>
-              <a:spcBef>
-                <a:spcPts val="500"/>
-              </a:spcBef>
-              <a:buFont typeface="Arial"/>
-              <a:buChar char="•"/>
-              <a:defRPr sz="1800" kern="1200">
-                <a:solidFill>
-                  <a:srgbClr val="00E2FF"/>
-                </a:solidFill>
-                <a:latin typeface="+mn-lt"/>
-                <a:ea typeface="+mn-ea"/>
-                <a:cs typeface="+mn-cs"/>
-              </a:defRPr>
-            </a:lvl5pPr>
-            <a:lvl6pPr marL="2514600" indent="-228600" algn="l" defTabSz="914400" rtl="0" eaLnBrk="1" latinLnBrk="0" hangingPunct="1">
-              <a:lnSpc>
-                <a:spcPct val="90000"/>
-              </a:lnSpc>
-              <a:spcBef>
-                <a:spcPts val="500"/>
-              </a:spcBef>
-              <a:buFont typeface="Arial"/>
-              <a:buChar char="•"/>
-              <a:defRPr sz="1800" kern="1200">
-                <a:solidFill>
-                  <a:schemeClr val="tx1"/>
-                </a:solidFill>
-                <a:latin typeface="+mn-lt"/>
-                <a:ea typeface="+mn-ea"/>
-                <a:cs typeface="+mn-cs"/>
-              </a:defRPr>
-            </a:lvl6pPr>
-            <a:lvl7pPr marL="2971800" indent="-228600" algn="l" defTabSz="914400" rtl="0" eaLnBrk="1" latinLnBrk="0" hangingPunct="1">
-              <a:lnSpc>
-                <a:spcPct val="90000"/>
-              </a:lnSpc>
-              <a:spcBef>
-                <a:spcPts val="500"/>
-              </a:spcBef>
-              <a:buFont typeface="Arial"/>
-              <a:buChar char="•"/>
-              <a:defRPr sz="1800" kern="1200">
-                <a:solidFill>
-                  <a:schemeClr val="tx1"/>
-                </a:solidFill>
-                <a:latin typeface="+mn-lt"/>
-                <a:ea typeface="+mn-ea"/>
-                <a:cs typeface="+mn-cs"/>
-              </a:defRPr>
-            </a:lvl7pPr>
-            <a:lvl8pPr marL="3429000" indent="-228600" algn="l" defTabSz="914400" rtl="0" eaLnBrk="1" latinLnBrk="0" hangingPunct="1">
-              <a:lnSpc>
-                <a:spcPct val="90000"/>
-              </a:lnSpc>
-              <a:spcBef>
-                <a:spcPts val="500"/>
-              </a:spcBef>
-              <a:buFont typeface="Arial"/>
-              <a:buChar char="•"/>
-              <a:defRPr sz="1800" kern="1200">
-                <a:solidFill>
-                  <a:schemeClr val="tx1"/>
-                </a:solidFill>
-                <a:latin typeface="+mn-lt"/>
-                <a:ea typeface="+mn-ea"/>
-                <a:cs typeface="+mn-cs"/>
-              </a:defRPr>
-            </a:lvl8pPr>
-            <a:lvl9pPr marL="3886200" indent="-228600" algn="l" defTabSz="914400" rtl="0" eaLnBrk="1" latinLnBrk="0" hangingPunct="1">
-              <a:lnSpc>
-                <a:spcPct val="90000"/>
-              </a:lnSpc>
-              <a:spcBef>
-                <a:spcPts val="500"/>
-              </a:spcBef>
-              <a:buFont typeface="Arial"/>
-              <a:buChar char="•"/>
-              <a:defRPr sz="1800" kern="1200">
-                <a:solidFill>
-                  <a:schemeClr val="tx1"/>
-                </a:solidFill>
-                <a:latin typeface="+mn-lt"/>
-                <a:ea typeface="+mn-ea"/>
-                <a:cs typeface="+mn-cs"/>
-              </a:defRPr>
-            </a:lvl9pPr>
-          </a:lstStyle>
-          <a:p>
-            <a:endParaRPr lang="en-US" dirty="0"/>
-          </a:p>
-        </p:txBody>
-      </p:sp>
-      <mc:AlternateContent xmlns:mc="http://schemas.openxmlformats.org/markup-compatibility/2006">
-        <mc:Choice xmlns:we="http://schemas.microsoft.com/office/webextensions/webextension/2010/11" xmlns:pca="http://schemas.microsoft.com/office/powerpoint/2013/contentapp" Requires="we pca">
-          <p:graphicFrame>
-            <p:nvGraphicFramePr>
-              <p:cNvPr id="2" name="Add-in 1">
-                <a:extLst>
-                  <a:ext uri="{FF2B5EF4-FFF2-40B4-BE49-F238E27FC236}">
-                    <a16:creationId xmlns:a16="http://schemas.microsoft.com/office/drawing/2014/main" id="{F1F174B0-FE5B-3090-4CDC-8A9DB0BA3B3A}"/>
-                  </a:ext>
-                </a:extLst>
-              </p:cNvPr>
-              <p:cNvGraphicFramePr>
-                <a:graphicFrameLocks noGrp="1"/>
-              </p:cNvGraphicFramePr>
-              <p:nvPr>
-                <p:extLst>
-                  <p:ext uri="{D42A27DB-BD31-4B8C-83A1-F6EECF244321}">
-                    <p14:modId xmlns:p14="http://schemas.microsoft.com/office/powerpoint/2010/main" val="1843969257"/>
-                  </p:ext>
-                </p:extLst>
-              </p:nvPr>
-            </p:nvGraphicFramePr>
-            <p:xfrm>
-              <a:off x="12687300" y="274864"/>
-              <a:ext cx="4686300" cy="5614308"/>
-            </p:xfrm>
-            <a:graphic>
-              <a:graphicData uri="http://schemas.microsoft.com/office/webextensions/webextension/2010/11">
-                <we:webextensionref xmlns:we="http://schemas.microsoft.com/office/webextensions/webextension/2010/11" xmlns:r="http://schemas.openxmlformats.org/officeDocument/2006/relationships" r:id="rId4"/>
-              </a:graphicData>
-            </a:graphic>
-          </p:graphicFrame>
-        </mc:Choice>
-        <mc:Fallback>
-          <p:pic>
-            <p:nvPicPr>
-              <p:cNvPr id="2" name="Add-in 1">
-                <a:extLst>
-                  <a:ext uri="{FF2B5EF4-FFF2-40B4-BE49-F238E27FC236}">
-                    <a16:creationId xmlns:a16="http://schemas.microsoft.com/office/drawing/2014/main" id="{F1F174B0-FE5B-3090-4CDC-8A9DB0BA3B3A}"/>
-                  </a:ext>
-                </a:extLst>
-              </p:cNvPr>
-              <p:cNvPicPr>
-                <a:picLocks noGrp="1" noRot="1" noChangeAspect="1" noMove="1" noResize="1" noEditPoints="1" noAdjustHandles="1" noChangeArrowheads="1" noChangeShapeType="1"/>
-              </p:cNvPicPr>
-              <p:nvPr/>
-            </p:nvPicPr>
-            <p:blipFill>
-              <a:blip r:embed="rId5"/>
-              <a:stretch>
-                <a:fillRect/>
-              </a:stretch>
-            </p:blipFill>
-            <p:spPr>
-              <a:xfrm>
-                <a:off x="12687300" y="274864"/>
-                <a:ext cx="4686300" cy="5614308"/>
-              </a:xfrm>
-              <a:prstGeom prst="rect">
-                <a:avLst/>
-              </a:prstGeom>
-            </p:spPr>
-          </p:pic>
-        </mc:Fallback>
-      </mc:AlternateContent>
-    </p:spTree>
-    <p:extLst>
-      <p:ext uri="{BB962C8B-B14F-4D97-AF65-F5344CB8AC3E}">
-        <p14:creationId xmlns:p14="http://schemas.microsoft.com/office/powerpoint/2010/main" val="1232860560"/>
-      </p:ext>
-    </p:extLst>
-  </p:cSld>
-  <p:clrMapOvr>
-    <a:masterClrMapping/>
-  </p:clrMapOvr>
-</p:sld>
-</file>
-
-<file path=ppt/slides/slide12.xml><?xml version="1.0" encoding="utf-8"?>
-<p:sld xmlns:a="http://schemas.openxmlformats.org/drawingml/2006/main" xmlns:r="http://schemas.openxmlformats.org/officeDocument/2006/relationships" xmlns:p="http://schemas.openxmlformats.org/presentationml/2006/main">
-  <p:cSld>
-    <p:bg>
-      <p:bgPr>
-        <a:blipFill dpi="0" rotWithShape="1">
-          <a:blip r:embed="rId3" cstate="print">
-            <a:lum/>
-            <a:extLst>
-              <a:ext uri="{28A0092B-C50C-407E-A947-70E740481C1C}">
-                <a14:useLocalDpi xmlns:a14="http://schemas.microsoft.com/office/drawing/2010/main"/>
-              </a:ext>
-            </a:extLst>
-          </a:blip>
-          <a:srcRect/>
-          <a:stretch>
-            <a:fillRect/>
-          </a:stretch>
-        </a:blipFill>
-        <a:effectLst/>
-      </p:bgPr>
-    </p:bg>
-    <p:spTree>
-      <p:nvGrpSpPr>
-        <p:cNvPr id="1" name="">
-          <a:extLst>
-            <a:ext uri="{FF2B5EF4-FFF2-40B4-BE49-F238E27FC236}">
               <a16:creationId xmlns:a16="http://schemas.microsoft.com/office/drawing/2014/main" id="{C725CA65-1D1C-35F6-4B69-B4B4CDBAD361}"/>
             </a:ext>
           </a:extLst>
@@ -8048,99 +6844,12 @@
           </a:p>
         </p:txBody>
       </p:sp>
-    </p:spTree>
-    <p:extLst>
-      <p:ext uri="{BB962C8B-B14F-4D97-AF65-F5344CB8AC3E}">
-        <p14:creationId xmlns:p14="http://schemas.microsoft.com/office/powerpoint/2010/main" val="1791411079"/>
-      </p:ext>
-    </p:extLst>
-  </p:cSld>
-  <p:clrMapOvr>
-    <a:masterClrMapping/>
-  </p:clrMapOvr>
-</p:sld>
-</file>
-
-<file path=ppt/slides/slide13.xml><?xml version="1.0" encoding="utf-8"?>
-<p:sld xmlns:a="http://schemas.openxmlformats.org/drawingml/2006/main" xmlns:r="http://schemas.openxmlformats.org/officeDocument/2006/relationships" xmlns:p="http://schemas.openxmlformats.org/presentationml/2006/main">
-  <p:cSld>
-    <p:bg>
-      <p:bgPr>
-        <a:blipFill dpi="0" rotWithShape="1">
-          <a:blip r:embed="rId3" cstate="print">
-            <a:lum/>
-            <a:extLst>
-              <a:ext uri="{28A0092B-C50C-407E-A947-70E740481C1C}">
-                <a14:useLocalDpi xmlns:a14="http://schemas.microsoft.com/office/drawing/2010/main"/>
-              </a:ext>
-            </a:extLst>
-          </a:blip>
-          <a:srcRect/>
-          <a:stretch>
-            <a:fillRect/>
-          </a:stretch>
-        </a:blipFill>
-        <a:effectLst/>
-      </p:bgPr>
-    </p:bg>
-    <p:spTree>
-      <p:nvGrpSpPr>
-        <p:cNvPr id="1" name="">
-          <a:extLst>
-            <a:ext uri="{FF2B5EF4-FFF2-40B4-BE49-F238E27FC236}">
-              <a16:creationId xmlns:a16="http://schemas.microsoft.com/office/drawing/2014/main" id="{54E3EB38-EB15-1947-3FD2-BBBE7CBE43C1}"/>
-            </a:ext>
-          </a:extLst>
-        </p:cNvPr>
-        <p:cNvGrpSpPr/>
-        <p:nvPr/>
-      </p:nvGrpSpPr>
-      <p:grpSpPr>
-        <a:xfrm>
-          <a:off x="0" y="0"/>
-          <a:ext cx="0" cy="0"/>
-          <a:chOff x="0" y="0"/>
-          <a:chExt cx="0" cy="0"/>
-        </a:xfrm>
-      </p:grpSpPr>
       <p:sp>
         <p:nvSpPr>
-          <p:cNvPr id="4" name="Text Placeholder 3">
+          <p:cNvPr id="2" name="Text Placeholder 3">
             <a:extLst>
               <a:ext uri="{FF2B5EF4-FFF2-40B4-BE49-F238E27FC236}">
-                <a16:creationId xmlns:a16="http://schemas.microsoft.com/office/drawing/2014/main" id="{AEDCE888-A35E-7E8E-12A7-28D5C06ADD16}"/>
-              </a:ext>
-            </a:extLst>
-          </p:cNvPr>
-          <p:cNvSpPr>
-            <a:spLocks noGrp="1"/>
-          </p:cNvSpPr>
-          <p:nvPr>
-            <p:ph type="body" sz="quarter" idx="10"/>
-          </p:nvPr>
-        </p:nvSpPr>
-        <p:spPr/>
-        <p:txBody>
-          <a:bodyPr lIns="91440" tIns="45720" rIns="91440" bIns="45720" anchor="t"/>
-          <a:lstStyle/>
-          <a:p>
-            <a:r>
-              <a:rPr lang="it-IT" dirty="0">
-                <a:latin typeface="Arial"/>
-                <a:cs typeface="Arial"/>
-              </a:rPr>
-              <a:t>GitHub actions</a:t>
-            </a:r>
-            <a:endParaRPr lang="en-US" dirty="0"/>
-          </a:p>
-        </p:txBody>
-      </p:sp>
-      <p:sp>
-        <p:nvSpPr>
-          <p:cNvPr id="6" name="Text Placeholder 3">
-            <a:extLst>
-              <a:ext uri="{FF2B5EF4-FFF2-40B4-BE49-F238E27FC236}">
-                <a16:creationId xmlns:a16="http://schemas.microsoft.com/office/drawing/2014/main" id="{025F3150-E0E8-6FA0-B677-61DBBCC27F13}"/>
+                <a16:creationId xmlns:a16="http://schemas.microsoft.com/office/drawing/2014/main" id="{8B8C9911-1E1C-2726-C60C-26A1C8978B2B}"/>
               </a:ext>
             </a:extLst>
           </p:cNvPr>
@@ -8151,7 +6860,7 @@
         </p:nvSpPr>
         <p:spPr>
           <a:xfrm>
-            <a:off x="6209198" y="4788827"/>
+            <a:off x="6361598" y="4941227"/>
             <a:ext cx="5445392" cy="849973"/>
           </a:xfrm>
           <a:prstGeom prst="rect">
@@ -8325,80 +7034,21 @@
             </a:lvl9pPr>
           </a:lstStyle>
           <a:p>
+            <a:r>
+              <a:rPr lang="en-IT" dirty="0">
+                <a:latin typeface="Arial"/>
+                <a:cs typeface="Arial"/>
+              </a:rPr>
+              <a:t>Yes, it's a demo</a:t>
+            </a:r>
             <a:endParaRPr lang="en-US" dirty="0"/>
           </a:p>
         </p:txBody>
       </p:sp>
-      <mc:AlternateContent xmlns:mc="http://schemas.openxmlformats.org/markup-compatibility/2006">
-        <mc:Choice xmlns:we="http://schemas.microsoft.com/office/webextensions/webextension/2010/11" xmlns:pca="http://schemas.microsoft.com/office/powerpoint/2013/contentapp" Requires="we pca">
-          <p:graphicFrame>
-            <p:nvGraphicFramePr>
-              <p:cNvPr id="2" name="Add-in 1">
-                <a:extLst>
-                  <a:ext uri="{FF2B5EF4-FFF2-40B4-BE49-F238E27FC236}">
-                    <a16:creationId xmlns:a16="http://schemas.microsoft.com/office/drawing/2014/main" id="{259E4729-93C9-3900-6DC4-27254095C5F2}"/>
-                  </a:ext>
-                </a:extLst>
-              </p:cNvPr>
-              <p:cNvGraphicFramePr>
-                <a:graphicFrameLocks noGrp="1"/>
-              </p:cNvGraphicFramePr>
-              <p:nvPr>
-                <p:extLst>
-                  <p:ext uri="{D42A27DB-BD31-4B8C-83A1-F6EECF244321}">
-                    <p14:modId xmlns:p14="http://schemas.microsoft.com/office/powerpoint/2010/main" val="3168493422"/>
-                  </p:ext>
-                </p:extLst>
-              </p:nvPr>
-            </p:nvGraphicFramePr>
-            <p:xfrm>
-              <a:off x="12710160" y="510538"/>
-              <a:ext cx="4743450" cy="5455921"/>
-            </p:xfrm>
-            <a:graphic>
-              <a:graphicData uri="http://schemas.microsoft.com/office/webextensions/webextension/2010/11">
-                <we:webextensionref xmlns:we="http://schemas.microsoft.com/office/webextensions/webextension/2010/11" xmlns:r="http://schemas.openxmlformats.org/officeDocument/2006/relationships" r:id="rId4"/>
-              </a:graphicData>
-            </a:graphic>
-          </p:graphicFrame>
-        </mc:Choice>
-        <mc:Fallback>
-          <p:pic>
-            <p:nvPicPr>
-              <p:cNvPr id="2" name="Add-in 1">
-                <a:extLst>
-                  <a:ext uri="{FF2B5EF4-FFF2-40B4-BE49-F238E27FC236}">
-                    <a16:creationId xmlns:a16="http://schemas.microsoft.com/office/drawing/2014/main" id="{259E4729-93C9-3900-6DC4-27254095C5F2}"/>
-                  </a:ext>
-                </a:extLst>
-              </p:cNvPr>
-              <p:cNvPicPr>
-                <a:picLocks noGrp="1" noRot="1" noChangeAspect="1" noMove="1" noResize="1" noEditPoints="1" noAdjustHandles="1" noChangeArrowheads="1" noChangeShapeType="1"/>
-              </p:cNvPicPr>
-              <p:nvPr/>
-            </p:nvPicPr>
-            <p:blipFill>
-              <a:blip r:embed="rId5"/>
-              <a:stretch>
-                <a:fillRect/>
-              </a:stretch>
-            </p:blipFill>
-            <p:spPr>
-              <a:xfrm>
-                <a:off x="12710160" y="510538"/>
-                <a:ext cx="4743450" cy="5455921"/>
-              </a:xfrm>
-              <a:prstGeom prst="rect">
-                <a:avLst/>
-              </a:prstGeom>
-            </p:spPr>
-          </p:pic>
-        </mc:Fallback>
-      </mc:AlternateContent>
     </p:spTree>
     <p:extLst>
       <p:ext uri="{BB962C8B-B14F-4D97-AF65-F5344CB8AC3E}">
-        <p14:creationId xmlns:p14="http://schemas.microsoft.com/office/powerpoint/2010/main" val="2712857754"/>
+        <p14:creationId xmlns:p14="http://schemas.microsoft.com/office/powerpoint/2010/main" val="1791411079"/>
       </p:ext>
     </p:extLst>
   </p:cSld>
@@ -8408,7 +7058,7 @@
 </p:sld>
 </file>
 
-<file path=ppt/slides/slide14.xml><?xml version="1.0" encoding="utf-8"?>
+<file path=ppt/slides/slide11.xml><?xml version="1.0" encoding="utf-8"?>
 <p:sld xmlns:a="http://schemas.openxmlformats.org/drawingml/2006/main" xmlns:r="http://schemas.openxmlformats.org/officeDocument/2006/relationships" xmlns:p="http://schemas.openxmlformats.org/presentationml/2006/main">
   <p:cSld>
     <p:bg>
@@ -8711,134 +7361,12 @@
           </a:p>
         </p:txBody>
       </p:sp>
-    </p:spTree>
-    <p:extLst>
-      <p:ext uri="{BB962C8B-B14F-4D97-AF65-F5344CB8AC3E}">
-        <p14:creationId xmlns:p14="http://schemas.microsoft.com/office/powerpoint/2010/main" val="3241895489"/>
-      </p:ext>
-    </p:extLst>
-  </p:cSld>
-  <p:clrMapOvr>
-    <a:masterClrMapping/>
-  </p:clrMapOvr>
-</p:sld>
-</file>
-
-<file path=ppt/slides/slide15.xml><?xml version="1.0" encoding="utf-8"?>
-<p:sld xmlns:a="http://schemas.openxmlformats.org/drawingml/2006/main" xmlns:r="http://schemas.openxmlformats.org/officeDocument/2006/relationships" xmlns:p="http://schemas.openxmlformats.org/presentationml/2006/main">
-  <p:cSld>
-    <p:bg>
-      <p:bgPr>
-        <a:blipFill dpi="0" rotWithShape="1">
-          <a:blip r:embed="rId3" cstate="print">
-            <a:lum/>
-            <a:extLst>
-              <a:ext uri="{28A0092B-C50C-407E-A947-70E740481C1C}">
-                <a14:useLocalDpi xmlns:a14="http://schemas.microsoft.com/office/drawing/2010/main"/>
-              </a:ext>
-            </a:extLst>
-          </a:blip>
-          <a:srcRect/>
-          <a:stretch>
-            <a:fillRect/>
-          </a:stretch>
-        </a:blipFill>
-        <a:effectLst/>
-      </p:bgPr>
-    </p:bg>
-    <p:spTree>
-      <p:nvGrpSpPr>
-        <p:cNvPr id="1" name="">
-          <a:extLst>
-            <a:ext uri="{FF2B5EF4-FFF2-40B4-BE49-F238E27FC236}">
-              <a16:creationId xmlns:a16="http://schemas.microsoft.com/office/drawing/2014/main" id="{13D8953E-EC56-1897-AF75-B211BE81F7C4}"/>
-            </a:ext>
-          </a:extLst>
-        </p:cNvPr>
-        <p:cNvGrpSpPr/>
-        <p:nvPr/>
-      </p:nvGrpSpPr>
-      <p:grpSpPr>
-        <a:xfrm>
-          <a:off x="0" y="0"/>
-          <a:ext cx="0" cy="0"/>
-          <a:chOff x="0" y="0"/>
-          <a:chExt cx="0" cy="0"/>
-        </a:xfrm>
-      </p:grpSpPr>
       <p:sp>
         <p:nvSpPr>
-          <p:cNvPr id="4" name="Text Placeholder 3">
+          <p:cNvPr id="2" name="Text Placeholder 3">
             <a:extLst>
               <a:ext uri="{FF2B5EF4-FFF2-40B4-BE49-F238E27FC236}">
-                <a16:creationId xmlns:a16="http://schemas.microsoft.com/office/drawing/2014/main" id="{D0178AF1-A378-3016-8683-09203D567CC4}"/>
-              </a:ext>
-            </a:extLst>
-          </p:cNvPr>
-          <p:cNvSpPr>
-            <a:spLocks noGrp="1"/>
-          </p:cNvSpPr>
-          <p:nvPr>
-            <p:ph type="body" sz="quarter" idx="10"/>
-          </p:nvPr>
-        </p:nvSpPr>
-        <p:spPr/>
-        <p:txBody>
-          <a:bodyPr lIns="91440" tIns="45720" rIns="91440" bIns="45720" anchor="t"/>
-          <a:lstStyle/>
-          <a:p>
-            <a:r>
-              <a:rPr lang="it-IT" dirty="0" err="1">
-                <a:latin typeface="Arial"/>
-                <a:cs typeface="Arial"/>
-              </a:rPr>
-              <a:t>Now</a:t>
-            </a:r>
-            <a:r>
-              <a:rPr lang="it-IT" dirty="0">
-                <a:latin typeface="Arial"/>
-                <a:cs typeface="Arial"/>
-              </a:rPr>
-              <a:t>, </a:t>
-            </a:r>
-            <a:r>
-              <a:rPr lang="it-IT" dirty="0" err="1">
-                <a:latin typeface="Arial"/>
-                <a:cs typeface="Arial"/>
-              </a:rPr>
-              <a:t>let’s</a:t>
-            </a:r>
-            <a:r>
-              <a:rPr lang="it-IT" dirty="0">
-                <a:latin typeface="Arial"/>
-                <a:cs typeface="Arial"/>
-              </a:rPr>
-              <a:t> make a </a:t>
-            </a:r>
-            <a:r>
-              <a:rPr lang="it-IT" dirty="0" err="1">
-                <a:latin typeface="Arial"/>
-                <a:cs typeface="Arial"/>
-              </a:rPr>
-              <a:t>change</a:t>
-            </a:r>
-            <a:r>
-              <a:rPr lang="it-IT" dirty="0">
-                <a:latin typeface="Arial"/>
-                <a:cs typeface="Arial"/>
-              </a:rPr>
-              <a:t>!</a:t>
-            </a:r>
-            <a:endParaRPr lang="en-US" dirty="0"/>
-          </a:p>
-        </p:txBody>
-      </p:sp>
-      <p:sp>
-        <p:nvSpPr>
-          <p:cNvPr id="6" name="Text Placeholder 3">
-            <a:extLst>
-              <a:ext uri="{FF2B5EF4-FFF2-40B4-BE49-F238E27FC236}">
-                <a16:creationId xmlns:a16="http://schemas.microsoft.com/office/drawing/2014/main" id="{3F330FA4-E096-0D3F-B79D-319B49698834}"/>
+                <a16:creationId xmlns:a16="http://schemas.microsoft.com/office/drawing/2014/main" id="{3A78386B-8BE4-FA7F-8A45-0993259E0E50}"/>
               </a:ext>
             </a:extLst>
           </p:cNvPr>
@@ -8849,7 +7377,7 @@
         </p:nvSpPr>
         <p:spPr>
           <a:xfrm>
-            <a:off x="6209198" y="4788827"/>
+            <a:off x="6361598" y="4941227"/>
             <a:ext cx="5445392" cy="849973"/>
           </a:xfrm>
           <a:prstGeom prst="rect">
@@ -9023,80 +7551,21 @@
             </a:lvl9pPr>
           </a:lstStyle>
           <a:p>
+            <a:r>
+              <a:rPr lang="en-IT" dirty="0">
+                <a:latin typeface="Arial"/>
+                <a:cs typeface="Arial"/>
+              </a:rPr>
+              <a:t>Yes, it's a demo</a:t>
+            </a:r>
             <a:endParaRPr lang="en-US" dirty="0"/>
           </a:p>
         </p:txBody>
       </p:sp>
-      <mc:AlternateContent xmlns:mc="http://schemas.openxmlformats.org/markup-compatibility/2006">
-        <mc:Choice xmlns:we="http://schemas.microsoft.com/office/webextensions/webextension/2010/11" xmlns:pca="http://schemas.microsoft.com/office/powerpoint/2013/contentapp" Requires="we pca">
-          <p:graphicFrame>
-            <p:nvGraphicFramePr>
-              <p:cNvPr id="2" name="Add-in 1">
-                <a:extLst>
-                  <a:ext uri="{FF2B5EF4-FFF2-40B4-BE49-F238E27FC236}">
-                    <a16:creationId xmlns:a16="http://schemas.microsoft.com/office/drawing/2014/main" id="{F10467F8-A133-FB87-24FB-0D850252A188}"/>
-                  </a:ext>
-                </a:extLst>
-              </p:cNvPr>
-              <p:cNvGraphicFramePr>
-                <a:graphicFrameLocks noGrp="1"/>
-              </p:cNvGraphicFramePr>
-              <p:nvPr>
-                <p:extLst>
-                  <p:ext uri="{D42A27DB-BD31-4B8C-83A1-F6EECF244321}">
-                    <p14:modId xmlns:p14="http://schemas.microsoft.com/office/powerpoint/2010/main" val="2470749793"/>
-                  </p:ext>
-                </p:extLst>
-              </p:nvPr>
-            </p:nvGraphicFramePr>
-            <p:xfrm>
-              <a:off x="12755880" y="590548"/>
-              <a:ext cx="5577840" cy="5330191"/>
-            </p:xfrm>
-            <a:graphic>
-              <a:graphicData uri="http://schemas.microsoft.com/office/webextensions/webextension/2010/11">
-                <we:webextensionref xmlns:we="http://schemas.microsoft.com/office/webextensions/webextension/2010/11" xmlns:r="http://schemas.openxmlformats.org/officeDocument/2006/relationships" r:id="rId4"/>
-              </a:graphicData>
-            </a:graphic>
-          </p:graphicFrame>
-        </mc:Choice>
-        <mc:Fallback>
-          <p:pic>
-            <p:nvPicPr>
-              <p:cNvPr id="2" name="Add-in 1">
-                <a:extLst>
-                  <a:ext uri="{FF2B5EF4-FFF2-40B4-BE49-F238E27FC236}">
-                    <a16:creationId xmlns:a16="http://schemas.microsoft.com/office/drawing/2014/main" id="{F10467F8-A133-FB87-24FB-0D850252A188}"/>
-                  </a:ext>
-                </a:extLst>
-              </p:cNvPr>
-              <p:cNvPicPr>
-                <a:picLocks noGrp="1" noRot="1" noChangeAspect="1" noMove="1" noResize="1" noEditPoints="1" noAdjustHandles="1" noChangeArrowheads="1" noChangeShapeType="1"/>
-              </p:cNvPicPr>
-              <p:nvPr/>
-            </p:nvPicPr>
-            <p:blipFill>
-              <a:blip r:embed="rId5"/>
-              <a:stretch>
-                <a:fillRect/>
-              </a:stretch>
-            </p:blipFill>
-            <p:spPr>
-              <a:xfrm>
-                <a:off x="12755880" y="590548"/>
-                <a:ext cx="5577840" cy="5330191"/>
-              </a:xfrm>
-              <a:prstGeom prst="rect">
-                <a:avLst/>
-              </a:prstGeom>
-            </p:spPr>
-          </p:pic>
-        </mc:Fallback>
-      </mc:AlternateContent>
     </p:spTree>
     <p:extLst>
       <p:ext uri="{BB962C8B-B14F-4D97-AF65-F5344CB8AC3E}">
-        <p14:creationId xmlns:p14="http://schemas.microsoft.com/office/powerpoint/2010/main" val="1744574347"/>
+        <p14:creationId xmlns:p14="http://schemas.microsoft.com/office/powerpoint/2010/main" val="3241895489"/>
       </p:ext>
     </p:extLst>
   </p:cSld>
@@ -9106,7 +7575,7 @@
 </p:sld>
 </file>
 
-<file path=ppt/slides/slide16.xml><?xml version="1.0" encoding="utf-8"?>
+<file path=ppt/slides/slide12.xml><?xml version="1.0" encoding="utf-8"?>
 <p:sld xmlns:a="http://schemas.openxmlformats.org/drawingml/2006/main" xmlns:r="http://schemas.openxmlformats.org/officeDocument/2006/relationships" xmlns:p="http://schemas.openxmlformats.org/presentationml/2006/main">
   <p:cSld>
     <p:bg>
@@ -9150,6 +7619,35 @@
       </p:grpSpPr>
       <p:sp>
         <p:nvSpPr>
+          <p:cNvPr id="2" name="Title 1">
+            <a:extLst>
+              <a:ext uri="{FF2B5EF4-FFF2-40B4-BE49-F238E27FC236}">
+                <a16:creationId xmlns:a16="http://schemas.microsoft.com/office/drawing/2014/main" id="{EB174F43-E0B4-56F1-2F81-F8EFE350D194}"/>
+              </a:ext>
+            </a:extLst>
+          </p:cNvPr>
+          <p:cNvSpPr>
+            <a:spLocks noGrp="1"/>
+          </p:cNvSpPr>
+          <p:nvPr>
+            <p:ph type="title"/>
+          </p:nvPr>
+        </p:nvSpPr>
+        <p:spPr/>
+        <p:txBody>
+          <a:bodyPr/>
+          <a:lstStyle/>
+          <a:p>
+            <a:r>
+              <a:rPr lang="it-IT" dirty="0"/>
+              <a:t>Wrap up</a:t>
+            </a:r>
+            <a:endParaRPr lang="en-US" dirty="0"/>
+          </a:p>
+        </p:txBody>
+      </p:sp>
+      <p:sp>
+        <p:nvSpPr>
           <p:cNvPr id="4" name="Text Placeholder 3">
             <a:extLst>
               <a:ext uri="{FF2B5EF4-FFF2-40B4-BE49-F238E27FC236}">
@@ -9161,7 +7659,7 @@
             <a:spLocks noGrp="1"/>
           </p:cNvSpPr>
           <p:nvPr>
-            <p:ph type="body" sz="quarter" idx="10"/>
+            <p:ph type="body" sz="quarter" idx="11"/>
           </p:nvPr>
         </p:nvSpPr>
         <p:spPr/>
@@ -9169,14 +7667,29 @@
           <a:bodyPr lIns="91440" tIns="45720" rIns="91440" bIns="45720" anchor="t"/>
           <a:lstStyle/>
           <a:p>
-            <a:r>
-              <a:rPr lang="en-IT">
+            <a:pPr marL="0" indent="0">
+              <a:buNone/>
+            </a:pPr>
+            <a:r>
+              <a:rPr lang="it-IT" dirty="0">
                 <a:latin typeface="Arial"/>
                 <a:cs typeface="Arial"/>
               </a:rPr>
-              <a:t>Wrap up</a:t>
-            </a:r>
-            <a:endParaRPr lang="en-US"/>
+              <a:t>Public repo:</a:t>
+            </a:r>
+          </a:p>
+          <a:p>
+            <a:pPr marL="0" indent="0">
+              <a:buNone/>
+            </a:pPr>
+            <a:r>
+              <a:rPr lang="en-IT" dirty="0">
+                <a:latin typeface="Arial"/>
+                <a:cs typeface="Arial"/>
+              </a:rPr>
+              <a:t>https://github.com/GuidoZam/espc-spfx-session-demo</a:t>
+            </a:r>
+            <a:endParaRPr lang="en-US" dirty="0"/>
           </a:p>
         </p:txBody>
       </p:sp>
@@ -9374,6 +7887,36 @@
           </a:p>
         </p:txBody>
       </p:sp>
+      <p:pic>
+        <p:nvPicPr>
+          <p:cNvPr id="5" name="Picture 4">
+            <a:extLst>
+              <a:ext uri="{FF2B5EF4-FFF2-40B4-BE49-F238E27FC236}">
+                <a16:creationId xmlns:a16="http://schemas.microsoft.com/office/drawing/2014/main" id="{E2BC3B9F-7E7B-E6C8-9727-3F09D8C9102B}"/>
+              </a:ext>
+            </a:extLst>
+          </p:cNvPr>
+          <p:cNvPicPr>
+            <a:picLocks noChangeAspect="1"/>
+          </p:cNvPicPr>
+          <p:nvPr/>
+        </p:nvPicPr>
+        <p:blipFill>
+          <a:blip r:embed="rId4"/>
+          <a:stretch>
+            <a:fillRect/>
+          </a:stretch>
+        </p:blipFill>
+        <p:spPr>
+          <a:xfrm>
+            <a:off x="7741560" y="2973771"/>
+            <a:ext cx="2665029" cy="2665029"/>
+          </a:xfrm>
+          <a:prstGeom prst="rect">
+            <a:avLst/>
+          </a:prstGeom>
+        </p:spPr>
+      </p:pic>
     </p:spTree>
     <p:extLst>
       <p:ext uri="{BB962C8B-B14F-4D97-AF65-F5344CB8AC3E}">
@@ -9387,7 +7930,7 @@
 </p:sld>
 </file>
 
-<file path=ppt/slides/slide17.xml><?xml version="1.0" encoding="utf-8"?>
+<file path=ppt/slides/slide13.xml><?xml version="1.0" encoding="utf-8"?>
 <p:sld xmlns:a="http://schemas.openxmlformats.org/drawingml/2006/main" xmlns:r="http://schemas.openxmlformats.org/officeDocument/2006/relationships" xmlns:p="http://schemas.openxmlformats.org/presentationml/2006/main">
   <p:cSld>
     <p:bg>
@@ -10389,8 +8932,35 @@
                 <a:latin typeface="Arial"/>
                 <a:cs typeface="Arial"/>
               </a:rPr>
-              <a:t>Let’s explore the solution</a:t>
-            </a:r>
+              <a:t>Let’s </a:t>
+            </a:r>
+            <a:r>
+              <a:rPr lang="it-IT" sz="4800" b="1" dirty="0" err="1">
+                <a:solidFill>
+                  <a:srgbClr val="00C700"/>
+                </a:solidFill>
+                <a:latin typeface="Arial"/>
+                <a:cs typeface="Arial"/>
+              </a:rPr>
+              <a:t>see</a:t>
+            </a:r>
+            <a:r>
+              <a:rPr lang="it-IT" sz="4800" b="1" dirty="0">
+                <a:solidFill>
+                  <a:srgbClr val="00C700"/>
+                </a:solidFill>
+                <a:latin typeface="Arial"/>
+                <a:cs typeface="Arial"/>
+              </a:rPr>
+              <a:t> the form</a:t>
+            </a:r>
+            <a:endParaRPr lang="en-IT" sz="4800" b="1" dirty="0">
+              <a:solidFill>
+                <a:srgbClr val="00C700"/>
+              </a:solidFill>
+              <a:latin typeface="Arial"/>
+              <a:cs typeface="Arial"/>
+            </a:endParaRPr>
           </a:p>
         </p:txBody>
       </p:sp>
@@ -10611,31 +9181,12 @@
 <file path=ppt/slides/slide7.xml><?xml version="1.0" encoding="utf-8"?>
 <p:sld xmlns:a="http://schemas.openxmlformats.org/drawingml/2006/main" xmlns:r="http://schemas.openxmlformats.org/officeDocument/2006/relationships" xmlns:p="http://schemas.openxmlformats.org/presentationml/2006/main">
   <p:cSld>
-    <p:bg>
-      <p:bgPr>
-        <a:blipFill dpi="0" rotWithShape="1">
-          <a:blip r:embed="rId3" cstate="print">
-            <a:lum/>
-            <a:extLst>
-              <a:ext uri="{28A0092B-C50C-407E-A947-70E740481C1C}">
-                <a14:useLocalDpi xmlns:a14="http://schemas.microsoft.com/office/drawing/2010/main"/>
-              </a:ext>
-            </a:extLst>
-          </a:blip>
-          <a:srcRect/>
-          <a:stretch>
-            <a:fillRect/>
-          </a:stretch>
-        </a:blipFill>
-        <a:effectLst/>
-      </p:bgPr>
-    </p:bg>
     <p:spTree>
       <p:nvGrpSpPr>
         <p:cNvPr id="1" name="">
           <a:extLst>
             <a:ext uri="{FF2B5EF4-FFF2-40B4-BE49-F238E27FC236}">
-              <a16:creationId xmlns:a16="http://schemas.microsoft.com/office/drawing/2014/main" id="{8F6AD8BF-776C-BDF6-EE6A-ABBA3886776E}"/>
+              <a16:creationId xmlns:a16="http://schemas.microsoft.com/office/drawing/2014/main" id="{74E19C68-9386-19AE-105F-51B68DF92FE3}"/>
             </a:ext>
           </a:extLst>
         </p:cNvPr>
@@ -10655,24 +9206,199 @@
           <p:cNvPr id="4" name="Text Placeholder 3">
             <a:extLst>
               <a:ext uri="{FF2B5EF4-FFF2-40B4-BE49-F238E27FC236}">
-                <a16:creationId xmlns:a16="http://schemas.microsoft.com/office/drawing/2014/main" id="{9179BCFB-57DC-8C0A-4753-100E56CE5122}"/>
+                <a16:creationId xmlns:a16="http://schemas.microsoft.com/office/drawing/2014/main" id="{5181D7CF-4862-7D2C-A698-CEFA40F5FE41}"/>
               </a:ext>
             </a:extLst>
           </p:cNvPr>
-          <p:cNvSpPr>
-            <a:spLocks noGrp="1"/>
+          <p:cNvSpPr txBox="1">
+            <a:spLocks/>
           </p:cNvSpPr>
-          <p:nvPr>
-            <p:ph type="body" sz="quarter" idx="10"/>
-          </p:nvPr>
+          <p:nvPr/>
         </p:nvSpPr>
-        <p:spPr/>
+        <p:spPr>
+          <a:xfrm>
+            <a:off x="737938" y="1628799"/>
+            <a:ext cx="10764252" cy="3857601"/>
+          </a:xfrm>
+          <a:prstGeom prst="rect">
+            <a:avLst/>
+          </a:prstGeom>
+        </p:spPr>
         <p:txBody>
           <a:bodyPr lIns="91440" tIns="45720" rIns="91440" bIns="45720" anchor="t"/>
-          <a:lstStyle/>
-          <a:p>
-            <a:r>
-              <a:rPr lang="en-IT">
+          <a:lstStyle>
+            <a:lvl1pPr marL="228600" indent="-228600" algn="l" defTabSz="914400" rtl="0" eaLnBrk="1" latinLnBrk="0" hangingPunct="1">
+              <a:lnSpc>
+                <a:spcPct val="90000"/>
+              </a:lnSpc>
+              <a:spcBef>
+                <a:spcPts val="1000"/>
+              </a:spcBef>
+              <a:buFont typeface="Arial"/>
+              <a:buChar char="•"/>
+              <a:defRPr sz="2800" kern="1200">
+                <a:solidFill>
+                  <a:schemeClr val="tx1"/>
+                </a:solidFill>
+                <a:latin typeface="+mn-lt"/>
+                <a:ea typeface="+mn-ea"/>
+                <a:cs typeface="+mn-cs"/>
+              </a:defRPr>
+            </a:lvl1pPr>
+            <a:lvl2pPr marL="685800" indent="-228600" algn="l" defTabSz="914400" rtl="0" eaLnBrk="1" latinLnBrk="0" hangingPunct="1">
+              <a:lnSpc>
+                <a:spcPct val="90000"/>
+              </a:lnSpc>
+              <a:spcBef>
+                <a:spcPts val="500"/>
+              </a:spcBef>
+              <a:buFont typeface="Arial"/>
+              <a:buChar char="•"/>
+              <a:defRPr sz="2400" kern="1200">
+                <a:solidFill>
+                  <a:schemeClr val="tx1"/>
+                </a:solidFill>
+                <a:latin typeface="+mn-lt"/>
+                <a:ea typeface="+mn-ea"/>
+                <a:cs typeface="+mn-cs"/>
+              </a:defRPr>
+            </a:lvl2pPr>
+            <a:lvl3pPr marL="1143000" indent="-228600" algn="l" defTabSz="914400" rtl="0" eaLnBrk="1" latinLnBrk="0" hangingPunct="1">
+              <a:lnSpc>
+                <a:spcPct val="90000"/>
+              </a:lnSpc>
+              <a:spcBef>
+                <a:spcPts val="500"/>
+              </a:spcBef>
+              <a:buFont typeface="Arial"/>
+              <a:buChar char="•"/>
+              <a:defRPr sz="2000" kern="1200">
+                <a:solidFill>
+                  <a:schemeClr val="tx1"/>
+                </a:solidFill>
+                <a:latin typeface="+mn-lt"/>
+                <a:ea typeface="+mn-ea"/>
+                <a:cs typeface="+mn-cs"/>
+              </a:defRPr>
+            </a:lvl3pPr>
+            <a:lvl4pPr marL="1600200" indent="-228600" algn="l" defTabSz="914400" rtl="0" eaLnBrk="1" latinLnBrk="0" hangingPunct="1">
+              <a:lnSpc>
+                <a:spcPct val="90000"/>
+              </a:lnSpc>
+              <a:spcBef>
+                <a:spcPts val="500"/>
+              </a:spcBef>
+              <a:buFont typeface="Arial"/>
+              <a:buChar char="•"/>
+              <a:defRPr sz="1800" kern="1200">
+                <a:solidFill>
+                  <a:schemeClr val="tx1"/>
+                </a:solidFill>
+                <a:latin typeface="+mn-lt"/>
+                <a:ea typeface="+mn-ea"/>
+                <a:cs typeface="+mn-cs"/>
+              </a:defRPr>
+            </a:lvl4pPr>
+            <a:lvl5pPr marL="2057400" indent="-228600" algn="l" defTabSz="914400" rtl="0" eaLnBrk="1" latinLnBrk="0" hangingPunct="1">
+              <a:lnSpc>
+                <a:spcPct val="90000"/>
+              </a:lnSpc>
+              <a:spcBef>
+                <a:spcPts val="500"/>
+              </a:spcBef>
+              <a:buFont typeface="Arial"/>
+              <a:buChar char="•"/>
+              <a:defRPr sz="1800" kern="1200">
+                <a:solidFill>
+                  <a:schemeClr val="tx1"/>
+                </a:solidFill>
+                <a:latin typeface="+mn-lt"/>
+                <a:ea typeface="+mn-ea"/>
+                <a:cs typeface="+mn-cs"/>
+              </a:defRPr>
+            </a:lvl5pPr>
+            <a:lvl6pPr marL="2514600" indent="-228600" algn="l" defTabSz="914400" rtl="0" eaLnBrk="1" latinLnBrk="0" hangingPunct="1">
+              <a:lnSpc>
+                <a:spcPct val="90000"/>
+              </a:lnSpc>
+              <a:spcBef>
+                <a:spcPts val="500"/>
+              </a:spcBef>
+              <a:buFont typeface="Arial"/>
+              <a:buChar char="•"/>
+              <a:defRPr sz="1800" kern="1200">
+                <a:solidFill>
+                  <a:schemeClr val="tx1"/>
+                </a:solidFill>
+                <a:latin typeface="+mn-lt"/>
+                <a:ea typeface="+mn-ea"/>
+                <a:cs typeface="+mn-cs"/>
+              </a:defRPr>
+            </a:lvl6pPr>
+            <a:lvl7pPr marL="2971800" indent="-228600" algn="l" defTabSz="914400" rtl="0" eaLnBrk="1" latinLnBrk="0" hangingPunct="1">
+              <a:lnSpc>
+                <a:spcPct val="90000"/>
+              </a:lnSpc>
+              <a:spcBef>
+                <a:spcPts val="500"/>
+              </a:spcBef>
+              <a:buFont typeface="Arial"/>
+              <a:buChar char="•"/>
+              <a:defRPr sz="1800" kern="1200">
+                <a:solidFill>
+                  <a:schemeClr val="tx1"/>
+                </a:solidFill>
+                <a:latin typeface="+mn-lt"/>
+                <a:ea typeface="+mn-ea"/>
+                <a:cs typeface="+mn-cs"/>
+              </a:defRPr>
+            </a:lvl7pPr>
+            <a:lvl8pPr marL="3429000" indent="-228600" algn="l" defTabSz="914400" rtl="0" eaLnBrk="1" latinLnBrk="0" hangingPunct="1">
+              <a:lnSpc>
+                <a:spcPct val="90000"/>
+              </a:lnSpc>
+              <a:spcBef>
+                <a:spcPts val="500"/>
+              </a:spcBef>
+              <a:buFont typeface="Arial"/>
+              <a:buChar char="•"/>
+              <a:defRPr sz="1800" kern="1200">
+                <a:solidFill>
+                  <a:schemeClr val="tx1"/>
+                </a:solidFill>
+                <a:latin typeface="+mn-lt"/>
+                <a:ea typeface="+mn-ea"/>
+                <a:cs typeface="+mn-cs"/>
+              </a:defRPr>
+            </a:lvl8pPr>
+            <a:lvl9pPr marL="3886200" indent="-228600" algn="l" defTabSz="914400" rtl="0" eaLnBrk="1" latinLnBrk="0" hangingPunct="1">
+              <a:lnSpc>
+                <a:spcPct val="90000"/>
+              </a:lnSpc>
+              <a:spcBef>
+                <a:spcPts val="500"/>
+              </a:spcBef>
+              <a:buFont typeface="Arial"/>
+              <a:buChar char="•"/>
+              <a:defRPr sz="1800" kern="1200">
+                <a:solidFill>
+                  <a:schemeClr val="tx1"/>
+                </a:solidFill>
+                <a:latin typeface="+mn-lt"/>
+                <a:ea typeface="+mn-ea"/>
+                <a:cs typeface="+mn-cs"/>
+              </a:defRPr>
+            </a:lvl9pPr>
+          </a:lstStyle>
+          <a:p>
+            <a:pPr marL="0" indent="0">
+              <a:buNone/>
+            </a:pPr>
+            <a:r>
+              <a:rPr lang="en-IT" sz="4800" b="1" dirty="0">
+                <a:solidFill>
+                  <a:srgbClr val="00C700"/>
+                </a:solidFill>
                 <a:latin typeface="Arial"/>
                 <a:cs typeface="Arial"/>
               </a:rPr>
@@ -10683,10 +9409,10 @@
       </p:sp>
       <p:sp>
         <p:nvSpPr>
-          <p:cNvPr id="6" name="Text Placeholder 3">
+          <p:cNvPr id="5" name="Text Placeholder 3">
             <a:extLst>
               <a:ext uri="{FF2B5EF4-FFF2-40B4-BE49-F238E27FC236}">
-                <a16:creationId xmlns:a16="http://schemas.microsoft.com/office/drawing/2014/main" id="{0681DA0A-CCBA-EB95-B7AD-406BDAC51C17}"/>
+                <a16:creationId xmlns:a16="http://schemas.microsoft.com/office/drawing/2014/main" id="{94934B45-769D-EB84-1026-D9DC4BBEDA19}"/>
               </a:ext>
             </a:extLst>
           </p:cNvPr>
@@ -10872,86 +9598,20 @@
           </a:lstStyle>
           <a:p>
             <a:r>
-              <a:rPr lang="en-IT">
+              <a:rPr lang="en-IT" dirty="0">
                 <a:latin typeface="Arial"/>
                 <a:cs typeface="Arial"/>
               </a:rPr>
               <a:t>Yes, it's a demo</a:t>
             </a:r>
-            <a:endParaRPr lang="en-US"/>
+            <a:endParaRPr lang="en-US" dirty="0"/>
           </a:p>
         </p:txBody>
       </p:sp>
-      <mc:AlternateContent xmlns:mc="http://schemas.openxmlformats.org/markup-compatibility/2006">
-        <mc:Choice xmlns:we="http://schemas.microsoft.com/office/webextensions/webextension/2010/11" xmlns:pca="http://schemas.microsoft.com/office/powerpoint/2013/contentapp" Requires="we pca">
-          <p:graphicFrame>
-            <p:nvGraphicFramePr>
-              <p:cNvPr id="3" name="Add-in 2">
-                <a:extLst>
-                  <a:ext uri="{FF2B5EF4-FFF2-40B4-BE49-F238E27FC236}">
-                    <a16:creationId xmlns:a16="http://schemas.microsoft.com/office/drawing/2014/main" id="{1CA29BF3-95FC-A0F7-B036-056A9ECD02AA}"/>
-                  </a:ext>
-                </a:extLst>
-              </p:cNvPr>
-              <p:cNvGraphicFramePr>
-                <a:graphicFrameLocks noGrp="1"/>
-              </p:cNvGraphicFramePr>
-              <p:nvPr>
-                <p:extLst>
-                  <p:ext uri="{D42A27DB-BD31-4B8C-83A1-F6EECF244321}">
-                    <p14:modId xmlns:p14="http://schemas.microsoft.com/office/powerpoint/2010/main" val="1464362284"/>
-                  </p:ext>
-                </p:extLst>
-              </p:nvPr>
-            </p:nvGraphicFramePr>
-            <p:xfrm>
-              <a:off x="12741728" y="547005"/>
-              <a:ext cx="5568043" cy="5505451"/>
-            </p:xfrm>
-            <a:graphic>
-              <a:graphicData uri="http://schemas.microsoft.com/office/webextensions/webextension/2010/11">
-                <we:webextensionref xmlns:we="http://schemas.microsoft.com/office/webextensions/webextension/2010/11" xmlns:r="http://schemas.openxmlformats.org/officeDocument/2006/relationships" r:id="rId4"/>
-              </a:graphicData>
-            </a:graphic>
-          </p:graphicFrame>
-        </mc:Choice>
-        <mc:Fallback>
-          <p:pic>
-            <p:nvPicPr>
-              <p:cNvPr id="3" name="Add-in 2">
-                <a:extLst>
-                  <a:ext uri="{FF2B5EF4-FFF2-40B4-BE49-F238E27FC236}">
-                    <a16:creationId xmlns:a16="http://schemas.microsoft.com/office/drawing/2014/main" id="{1CA29BF3-95FC-A0F7-B036-056A9ECD02AA}"/>
-                  </a:ext>
-                </a:extLst>
-              </p:cNvPr>
-              <p:cNvPicPr>
-                <a:picLocks noGrp="1" noRot="1" noChangeAspect="1" noMove="1" noResize="1" noEditPoints="1" noAdjustHandles="1" noChangeArrowheads="1" noChangeShapeType="1"/>
-              </p:cNvPicPr>
-              <p:nvPr/>
-            </p:nvPicPr>
-            <p:blipFill>
-              <a:blip r:embed="rId5"/>
-              <a:stretch>
-                <a:fillRect/>
-              </a:stretch>
-            </p:blipFill>
-            <p:spPr>
-              <a:xfrm>
-                <a:off x="12741728" y="547005"/>
-                <a:ext cx="5568043" cy="5505451"/>
-              </a:xfrm>
-              <a:prstGeom prst="rect">
-                <a:avLst/>
-              </a:prstGeom>
-            </p:spPr>
-          </p:pic>
-        </mc:Fallback>
-      </mc:AlternateContent>
     </p:spTree>
     <p:extLst>
       <p:ext uri="{BB962C8B-B14F-4D97-AF65-F5344CB8AC3E}">
-        <p14:creationId xmlns:p14="http://schemas.microsoft.com/office/powerpoint/2010/main" val="1168151202"/>
+        <p14:creationId xmlns:p14="http://schemas.microsoft.com/office/powerpoint/2010/main" val="3104044014"/>
       </p:ext>
     </p:extLst>
   </p:cSld>
@@ -11239,6 +9899,207 @@
           </a:p>
         </p:txBody>
       </p:sp>
+      <p:sp>
+        <p:nvSpPr>
+          <p:cNvPr id="2" name="Text Placeholder 3">
+            <a:extLst>
+              <a:ext uri="{FF2B5EF4-FFF2-40B4-BE49-F238E27FC236}">
+                <a16:creationId xmlns:a16="http://schemas.microsoft.com/office/drawing/2014/main" id="{1B12BF3B-4688-0992-8EB8-D4AAABCB7FCE}"/>
+              </a:ext>
+            </a:extLst>
+          </p:cNvPr>
+          <p:cNvSpPr txBox="1">
+            <a:spLocks/>
+          </p:cNvSpPr>
+          <p:nvPr/>
+        </p:nvSpPr>
+        <p:spPr>
+          <a:xfrm>
+            <a:off x="6361598" y="4941227"/>
+            <a:ext cx="5445392" cy="849973"/>
+          </a:xfrm>
+          <a:prstGeom prst="rect">
+            <a:avLst/>
+          </a:prstGeom>
+        </p:spPr>
+        <p:txBody>
+          <a:bodyPr lIns="91440" tIns="45720" rIns="91440" bIns="45720" anchor="t"/>
+          <a:lstStyle>
+            <a:lvl1pPr marL="0" indent="0" algn="l" defTabSz="914400" rtl="0" eaLnBrk="1" latinLnBrk="0" hangingPunct="1">
+              <a:lnSpc>
+                <a:spcPct val="90000"/>
+              </a:lnSpc>
+              <a:spcBef>
+                <a:spcPts val="1000"/>
+              </a:spcBef>
+              <a:buFont typeface="Arial"/>
+              <a:buNone/>
+              <a:defRPr sz="4800" b="1" kern="1200">
+                <a:solidFill>
+                  <a:srgbClr val="00C700"/>
+                </a:solidFill>
+                <a:latin typeface="Arial" panose="020B0604020202020204" pitchFamily="34" charset="0"/>
+                <a:ea typeface="+mn-ea"/>
+                <a:cs typeface="Arial" panose="020B0604020202020204" pitchFamily="34" charset="0"/>
+              </a:defRPr>
+            </a:lvl1pPr>
+            <a:lvl2pPr marL="685800" indent="-228600" algn="l" defTabSz="914400" rtl="0" eaLnBrk="1" latinLnBrk="0" hangingPunct="1">
+              <a:lnSpc>
+                <a:spcPct val="90000"/>
+              </a:lnSpc>
+              <a:spcBef>
+                <a:spcPts val="500"/>
+              </a:spcBef>
+              <a:buFont typeface="Arial"/>
+              <a:buChar char="•"/>
+              <a:defRPr sz="2400" kern="1200">
+                <a:solidFill>
+                  <a:srgbClr val="00E2FF"/>
+                </a:solidFill>
+                <a:latin typeface="+mn-lt"/>
+                <a:ea typeface="+mn-ea"/>
+                <a:cs typeface="+mn-cs"/>
+              </a:defRPr>
+            </a:lvl2pPr>
+            <a:lvl3pPr marL="1143000" indent="-228600" algn="l" defTabSz="914400" rtl="0" eaLnBrk="1" latinLnBrk="0" hangingPunct="1">
+              <a:lnSpc>
+                <a:spcPct val="90000"/>
+              </a:lnSpc>
+              <a:spcBef>
+                <a:spcPts val="500"/>
+              </a:spcBef>
+              <a:buFont typeface="Arial"/>
+              <a:buChar char="•"/>
+              <a:defRPr sz="2000" kern="1200">
+                <a:solidFill>
+                  <a:srgbClr val="00E2FF"/>
+                </a:solidFill>
+                <a:latin typeface="+mn-lt"/>
+                <a:ea typeface="+mn-ea"/>
+                <a:cs typeface="+mn-cs"/>
+              </a:defRPr>
+            </a:lvl3pPr>
+            <a:lvl4pPr marL="1600200" indent="-228600" algn="l" defTabSz="914400" rtl="0" eaLnBrk="1" latinLnBrk="0" hangingPunct="1">
+              <a:lnSpc>
+                <a:spcPct val="90000"/>
+              </a:lnSpc>
+              <a:spcBef>
+                <a:spcPts val="500"/>
+              </a:spcBef>
+              <a:buFont typeface="Arial"/>
+              <a:buChar char="•"/>
+              <a:defRPr sz="1800" kern="1200">
+                <a:solidFill>
+                  <a:srgbClr val="00E2FF"/>
+                </a:solidFill>
+                <a:latin typeface="+mn-lt"/>
+                <a:ea typeface="+mn-ea"/>
+                <a:cs typeface="+mn-cs"/>
+              </a:defRPr>
+            </a:lvl4pPr>
+            <a:lvl5pPr marL="2057400" indent="-228600" algn="l" defTabSz="914400" rtl="0" eaLnBrk="1" latinLnBrk="0" hangingPunct="1">
+              <a:lnSpc>
+                <a:spcPct val="90000"/>
+              </a:lnSpc>
+              <a:spcBef>
+                <a:spcPts val="500"/>
+              </a:spcBef>
+              <a:buFont typeface="Arial"/>
+              <a:buChar char="•"/>
+              <a:defRPr sz="1800" kern="1200">
+                <a:solidFill>
+                  <a:srgbClr val="00E2FF"/>
+                </a:solidFill>
+                <a:latin typeface="+mn-lt"/>
+                <a:ea typeface="+mn-ea"/>
+                <a:cs typeface="+mn-cs"/>
+              </a:defRPr>
+            </a:lvl5pPr>
+            <a:lvl6pPr marL="2514600" indent="-228600" algn="l" defTabSz="914400" rtl="0" eaLnBrk="1" latinLnBrk="0" hangingPunct="1">
+              <a:lnSpc>
+                <a:spcPct val="90000"/>
+              </a:lnSpc>
+              <a:spcBef>
+                <a:spcPts val="500"/>
+              </a:spcBef>
+              <a:buFont typeface="Arial"/>
+              <a:buChar char="•"/>
+              <a:defRPr sz="1800" kern="1200">
+                <a:solidFill>
+                  <a:schemeClr val="tx1"/>
+                </a:solidFill>
+                <a:latin typeface="+mn-lt"/>
+                <a:ea typeface="+mn-ea"/>
+                <a:cs typeface="+mn-cs"/>
+              </a:defRPr>
+            </a:lvl6pPr>
+            <a:lvl7pPr marL="2971800" indent="-228600" algn="l" defTabSz="914400" rtl="0" eaLnBrk="1" latinLnBrk="0" hangingPunct="1">
+              <a:lnSpc>
+                <a:spcPct val="90000"/>
+              </a:lnSpc>
+              <a:spcBef>
+                <a:spcPts val="500"/>
+              </a:spcBef>
+              <a:buFont typeface="Arial"/>
+              <a:buChar char="•"/>
+              <a:defRPr sz="1800" kern="1200">
+                <a:solidFill>
+                  <a:schemeClr val="tx1"/>
+                </a:solidFill>
+                <a:latin typeface="+mn-lt"/>
+                <a:ea typeface="+mn-ea"/>
+                <a:cs typeface="+mn-cs"/>
+              </a:defRPr>
+            </a:lvl7pPr>
+            <a:lvl8pPr marL="3429000" indent="-228600" algn="l" defTabSz="914400" rtl="0" eaLnBrk="1" latinLnBrk="0" hangingPunct="1">
+              <a:lnSpc>
+                <a:spcPct val="90000"/>
+              </a:lnSpc>
+              <a:spcBef>
+                <a:spcPts val="500"/>
+              </a:spcBef>
+              <a:buFont typeface="Arial"/>
+              <a:buChar char="•"/>
+              <a:defRPr sz="1800" kern="1200">
+                <a:solidFill>
+                  <a:schemeClr val="tx1"/>
+                </a:solidFill>
+                <a:latin typeface="+mn-lt"/>
+                <a:ea typeface="+mn-ea"/>
+                <a:cs typeface="+mn-cs"/>
+              </a:defRPr>
+            </a:lvl8pPr>
+            <a:lvl9pPr marL="3886200" indent="-228600" algn="l" defTabSz="914400" rtl="0" eaLnBrk="1" latinLnBrk="0" hangingPunct="1">
+              <a:lnSpc>
+                <a:spcPct val="90000"/>
+              </a:lnSpc>
+              <a:spcBef>
+                <a:spcPts val="500"/>
+              </a:spcBef>
+              <a:buFont typeface="Arial"/>
+              <a:buChar char="•"/>
+              <a:defRPr sz="1800" kern="1200">
+                <a:solidFill>
+                  <a:schemeClr val="tx1"/>
+                </a:solidFill>
+                <a:latin typeface="+mn-lt"/>
+                <a:ea typeface="+mn-ea"/>
+                <a:cs typeface="+mn-cs"/>
+              </a:defRPr>
+            </a:lvl9pPr>
+          </a:lstStyle>
+          <a:p>
+            <a:r>
+              <a:rPr lang="en-IT" dirty="0">
+                <a:latin typeface="Arial"/>
+                <a:cs typeface="Arial"/>
+              </a:rPr>
+              <a:t>Yes, it's a demo</a:t>
+            </a:r>
+            <a:endParaRPr lang="en-US" dirty="0"/>
+          </a:p>
+        </p:txBody>
+      </p:sp>
     </p:spTree>
     <p:extLst>
       <p:ext uri="{BB962C8B-B14F-4D97-AF65-F5344CB8AC3E}">
@@ -11279,7 +10140,7 @@
         <p:cNvPr id="1" name="">
           <a:extLst>
             <a:ext uri="{FF2B5EF4-FFF2-40B4-BE49-F238E27FC236}">
-              <a16:creationId xmlns:a16="http://schemas.microsoft.com/office/drawing/2014/main" id="{DD9AFB09-250B-3A1B-C09E-6E6AD18C9D8D}"/>
+              <a16:creationId xmlns:a16="http://schemas.microsoft.com/office/drawing/2014/main" id="{CE6AA263-EDC0-82B9-0839-92AF21ACE1CD}"/>
             </a:ext>
           </a:extLst>
         </p:cNvPr>
@@ -11299,7 +10160,7 @@
           <p:cNvPr id="4" name="Text Placeholder 3">
             <a:extLst>
               <a:ext uri="{FF2B5EF4-FFF2-40B4-BE49-F238E27FC236}">
-                <a16:creationId xmlns:a16="http://schemas.microsoft.com/office/drawing/2014/main" id="{7F6A3742-4B7B-4C4F-4217-8532368F9692}"/>
+                <a16:creationId xmlns:a16="http://schemas.microsoft.com/office/drawing/2014/main" id="{0CBA97D0-9053-786F-6374-AD269EB13774}"/>
               </a:ext>
             </a:extLst>
           </p:cNvPr>
@@ -11316,21 +10177,18 @@
           <a:lstStyle/>
           <a:p>
             <a:r>
+              <a:rPr lang="it-IT" dirty="0">
+                <a:latin typeface="Arial"/>
+                <a:cs typeface="Arial"/>
+              </a:rPr>
+              <a:t>e2e</a:t>
+            </a:r>
+            <a:r>
               <a:rPr lang="en-IT" dirty="0">
                 <a:latin typeface="Arial"/>
                 <a:cs typeface="Arial"/>
               </a:rPr>
-              <a:t>Unit testing</a:t>
-            </a:r>
-            <a:endParaRPr lang="en-US"/>
-          </a:p>
-          <a:p>
-            <a:r>
-              <a:rPr lang="en-US">
-                <a:latin typeface="Arial"/>
-                <a:cs typeface="Arial"/>
-              </a:rPr>
-              <a:t>Business logic</a:t>
+              <a:t> testing</a:t>
             </a:r>
             <a:endParaRPr lang="en-US" dirty="0"/>
           </a:p>
@@ -11341,7 +10199,7 @@
           <p:cNvPr id="6" name="Text Placeholder 3">
             <a:extLst>
               <a:ext uri="{FF2B5EF4-FFF2-40B4-BE49-F238E27FC236}">
-                <a16:creationId xmlns:a16="http://schemas.microsoft.com/office/drawing/2014/main" id="{031EFA2E-CC08-4E61-C8EC-6D7EC82AAA4C}"/>
+                <a16:creationId xmlns:a16="http://schemas.microsoft.com/office/drawing/2014/main" id="{BDFF9A42-A75A-359A-8534-541E28FE0BB2}"/>
               </a:ext>
             </a:extLst>
           </p:cNvPr>
@@ -11530,76 +10388,211 @@
           </a:p>
         </p:txBody>
       </p:sp>
-      <mc:AlternateContent xmlns:mc="http://schemas.openxmlformats.org/markup-compatibility/2006">
-        <mc:Choice xmlns:we="http://schemas.microsoft.com/office/webextensions/webextension/2010/11" xmlns:pca="http://schemas.microsoft.com/office/powerpoint/2013/contentapp" Requires="we pca">
-          <p:graphicFrame>
-            <p:nvGraphicFramePr>
-              <p:cNvPr id="2" name="Add-in 1">
-                <a:extLst>
-                  <a:ext uri="{FF2B5EF4-FFF2-40B4-BE49-F238E27FC236}">
-                    <a16:creationId xmlns:a16="http://schemas.microsoft.com/office/drawing/2014/main" id="{A45B9582-E3B7-5FD5-D1EC-C428FFBF9EC2}"/>
-                  </a:ext>
-                </a:extLst>
-              </p:cNvPr>
-              <p:cNvGraphicFramePr>
-                <a:graphicFrameLocks noGrp="1"/>
-              </p:cNvGraphicFramePr>
-              <p:nvPr>
-                <p:extLst>
-                  <p:ext uri="{D42A27DB-BD31-4B8C-83A1-F6EECF244321}">
-                    <p14:modId xmlns:p14="http://schemas.microsoft.com/office/powerpoint/2010/main" val="4113641312"/>
-                  </p:ext>
-                </p:extLst>
-              </p:nvPr>
-            </p:nvGraphicFramePr>
-            <p:xfrm>
-              <a:off x="12687299" y="490945"/>
-              <a:ext cx="5546271" cy="5603422"/>
-            </p:xfrm>
-            <a:graphic>
-              <a:graphicData uri="http://schemas.microsoft.com/office/webextensions/webextension/2010/11">
-                <we:webextensionref xmlns:we="http://schemas.microsoft.com/office/webextensions/webextension/2010/11" xmlns:r="http://schemas.openxmlformats.org/officeDocument/2006/relationships" r:id="rId4"/>
-              </a:graphicData>
-            </a:graphic>
-          </p:graphicFrame>
-        </mc:Choice>
-        <mc:Fallback>
-          <p:pic>
-            <p:nvPicPr>
-              <p:cNvPr id="2" name="Add-in 1">
-                <a:extLst>
-                  <a:ext uri="{FF2B5EF4-FFF2-40B4-BE49-F238E27FC236}">
-                    <a16:creationId xmlns:a16="http://schemas.microsoft.com/office/drawing/2014/main" id="{A45B9582-E3B7-5FD5-D1EC-C428FFBF9EC2}"/>
-                  </a:ext>
-                </a:extLst>
-              </p:cNvPr>
-              <p:cNvPicPr>
-                <a:picLocks noGrp="1" noRot="1" noChangeAspect="1" noMove="1" noResize="1" noEditPoints="1" noAdjustHandles="1" noChangeArrowheads="1" noChangeShapeType="1"/>
-              </p:cNvPicPr>
-              <p:nvPr/>
-            </p:nvPicPr>
-            <p:blipFill>
-              <a:blip r:embed="rId5"/>
-              <a:stretch>
-                <a:fillRect/>
-              </a:stretch>
-            </p:blipFill>
-            <p:spPr>
-              <a:xfrm>
-                <a:off x="12687299" y="490945"/>
-                <a:ext cx="5546271" cy="5603422"/>
-              </a:xfrm>
-              <a:prstGeom prst="rect">
-                <a:avLst/>
-              </a:prstGeom>
-            </p:spPr>
-          </p:pic>
-        </mc:Fallback>
-      </mc:AlternateContent>
+      <p:sp>
+        <p:nvSpPr>
+          <p:cNvPr id="2" name="Text Placeholder 3">
+            <a:extLst>
+              <a:ext uri="{FF2B5EF4-FFF2-40B4-BE49-F238E27FC236}">
+                <a16:creationId xmlns:a16="http://schemas.microsoft.com/office/drawing/2014/main" id="{AFAEDE67-5200-687D-2622-25016CB5F05D}"/>
+              </a:ext>
+            </a:extLst>
+          </p:cNvPr>
+          <p:cNvSpPr txBox="1">
+            <a:spLocks/>
+          </p:cNvSpPr>
+          <p:nvPr/>
+        </p:nvSpPr>
+        <p:spPr>
+          <a:xfrm>
+            <a:off x="6361598" y="4941227"/>
+            <a:ext cx="5445392" cy="849973"/>
+          </a:xfrm>
+          <a:prstGeom prst="rect">
+            <a:avLst/>
+          </a:prstGeom>
+        </p:spPr>
+        <p:txBody>
+          <a:bodyPr lIns="91440" tIns="45720" rIns="91440" bIns="45720" anchor="t"/>
+          <a:lstStyle>
+            <a:lvl1pPr marL="0" indent="0" algn="l" defTabSz="914400" rtl="0" eaLnBrk="1" latinLnBrk="0" hangingPunct="1">
+              <a:lnSpc>
+                <a:spcPct val="90000"/>
+              </a:lnSpc>
+              <a:spcBef>
+                <a:spcPts val="1000"/>
+              </a:spcBef>
+              <a:buFont typeface="Arial"/>
+              <a:buNone/>
+              <a:defRPr sz="4800" b="1" kern="1200">
+                <a:solidFill>
+                  <a:srgbClr val="00C700"/>
+                </a:solidFill>
+                <a:latin typeface="Arial" panose="020B0604020202020204" pitchFamily="34" charset="0"/>
+                <a:ea typeface="+mn-ea"/>
+                <a:cs typeface="Arial" panose="020B0604020202020204" pitchFamily="34" charset="0"/>
+              </a:defRPr>
+            </a:lvl1pPr>
+            <a:lvl2pPr marL="685800" indent="-228600" algn="l" defTabSz="914400" rtl="0" eaLnBrk="1" latinLnBrk="0" hangingPunct="1">
+              <a:lnSpc>
+                <a:spcPct val="90000"/>
+              </a:lnSpc>
+              <a:spcBef>
+                <a:spcPts val="500"/>
+              </a:spcBef>
+              <a:buFont typeface="Arial"/>
+              <a:buChar char="•"/>
+              <a:defRPr sz="2400" kern="1200">
+                <a:solidFill>
+                  <a:srgbClr val="00E2FF"/>
+                </a:solidFill>
+                <a:latin typeface="+mn-lt"/>
+                <a:ea typeface="+mn-ea"/>
+                <a:cs typeface="+mn-cs"/>
+              </a:defRPr>
+            </a:lvl2pPr>
+            <a:lvl3pPr marL="1143000" indent="-228600" algn="l" defTabSz="914400" rtl="0" eaLnBrk="1" latinLnBrk="0" hangingPunct="1">
+              <a:lnSpc>
+                <a:spcPct val="90000"/>
+              </a:lnSpc>
+              <a:spcBef>
+                <a:spcPts val="500"/>
+              </a:spcBef>
+              <a:buFont typeface="Arial"/>
+              <a:buChar char="•"/>
+              <a:defRPr sz="2000" kern="1200">
+                <a:solidFill>
+                  <a:srgbClr val="00E2FF"/>
+                </a:solidFill>
+                <a:latin typeface="+mn-lt"/>
+                <a:ea typeface="+mn-ea"/>
+                <a:cs typeface="+mn-cs"/>
+              </a:defRPr>
+            </a:lvl3pPr>
+            <a:lvl4pPr marL="1600200" indent="-228600" algn="l" defTabSz="914400" rtl="0" eaLnBrk="1" latinLnBrk="0" hangingPunct="1">
+              <a:lnSpc>
+                <a:spcPct val="90000"/>
+              </a:lnSpc>
+              <a:spcBef>
+                <a:spcPts val="500"/>
+              </a:spcBef>
+              <a:buFont typeface="Arial"/>
+              <a:buChar char="•"/>
+              <a:defRPr sz="1800" kern="1200">
+                <a:solidFill>
+                  <a:srgbClr val="00E2FF"/>
+                </a:solidFill>
+                <a:latin typeface="+mn-lt"/>
+                <a:ea typeface="+mn-ea"/>
+                <a:cs typeface="+mn-cs"/>
+              </a:defRPr>
+            </a:lvl4pPr>
+            <a:lvl5pPr marL="2057400" indent="-228600" algn="l" defTabSz="914400" rtl="0" eaLnBrk="1" latinLnBrk="0" hangingPunct="1">
+              <a:lnSpc>
+                <a:spcPct val="90000"/>
+              </a:lnSpc>
+              <a:spcBef>
+                <a:spcPts val="500"/>
+              </a:spcBef>
+              <a:buFont typeface="Arial"/>
+              <a:buChar char="•"/>
+              <a:defRPr sz="1800" kern="1200">
+                <a:solidFill>
+                  <a:srgbClr val="00E2FF"/>
+                </a:solidFill>
+                <a:latin typeface="+mn-lt"/>
+                <a:ea typeface="+mn-ea"/>
+                <a:cs typeface="+mn-cs"/>
+              </a:defRPr>
+            </a:lvl5pPr>
+            <a:lvl6pPr marL="2514600" indent="-228600" algn="l" defTabSz="914400" rtl="0" eaLnBrk="1" latinLnBrk="0" hangingPunct="1">
+              <a:lnSpc>
+                <a:spcPct val="90000"/>
+              </a:lnSpc>
+              <a:spcBef>
+                <a:spcPts val="500"/>
+              </a:spcBef>
+              <a:buFont typeface="Arial"/>
+              <a:buChar char="•"/>
+              <a:defRPr sz="1800" kern="1200">
+                <a:solidFill>
+                  <a:schemeClr val="tx1"/>
+                </a:solidFill>
+                <a:latin typeface="+mn-lt"/>
+                <a:ea typeface="+mn-ea"/>
+                <a:cs typeface="+mn-cs"/>
+              </a:defRPr>
+            </a:lvl6pPr>
+            <a:lvl7pPr marL="2971800" indent="-228600" algn="l" defTabSz="914400" rtl="0" eaLnBrk="1" latinLnBrk="0" hangingPunct="1">
+              <a:lnSpc>
+                <a:spcPct val="90000"/>
+              </a:lnSpc>
+              <a:spcBef>
+                <a:spcPts val="500"/>
+              </a:spcBef>
+              <a:buFont typeface="Arial"/>
+              <a:buChar char="•"/>
+              <a:defRPr sz="1800" kern="1200">
+                <a:solidFill>
+                  <a:schemeClr val="tx1"/>
+                </a:solidFill>
+                <a:latin typeface="+mn-lt"/>
+                <a:ea typeface="+mn-ea"/>
+                <a:cs typeface="+mn-cs"/>
+              </a:defRPr>
+            </a:lvl7pPr>
+            <a:lvl8pPr marL="3429000" indent="-228600" algn="l" defTabSz="914400" rtl="0" eaLnBrk="1" latinLnBrk="0" hangingPunct="1">
+              <a:lnSpc>
+                <a:spcPct val="90000"/>
+              </a:lnSpc>
+              <a:spcBef>
+                <a:spcPts val="500"/>
+              </a:spcBef>
+              <a:buFont typeface="Arial"/>
+              <a:buChar char="•"/>
+              <a:defRPr sz="1800" kern="1200">
+                <a:solidFill>
+                  <a:schemeClr val="tx1"/>
+                </a:solidFill>
+                <a:latin typeface="+mn-lt"/>
+                <a:ea typeface="+mn-ea"/>
+                <a:cs typeface="+mn-cs"/>
+              </a:defRPr>
+            </a:lvl8pPr>
+            <a:lvl9pPr marL="3886200" indent="-228600" algn="l" defTabSz="914400" rtl="0" eaLnBrk="1" latinLnBrk="0" hangingPunct="1">
+              <a:lnSpc>
+                <a:spcPct val="90000"/>
+              </a:lnSpc>
+              <a:spcBef>
+                <a:spcPts val="500"/>
+              </a:spcBef>
+              <a:buFont typeface="Arial"/>
+              <a:buChar char="•"/>
+              <a:defRPr sz="1800" kern="1200">
+                <a:solidFill>
+                  <a:schemeClr val="tx1"/>
+                </a:solidFill>
+                <a:latin typeface="+mn-lt"/>
+                <a:ea typeface="+mn-ea"/>
+                <a:cs typeface="+mn-cs"/>
+              </a:defRPr>
+            </a:lvl9pPr>
+          </a:lstStyle>
+          <a:p>
+            <a:r>
+              <a:rPr lang="en-IT" dirty="0">
+                <a:latin typeface="Arial"/>
+                <a:cs typeface="Arial"/>
+              </a:rPr>
+              <a:t>Yes, it's a demo</a:t>
+            </a:r>
+            <a:endParaRPr lang="en-US" dirty="0"/>
+          </a:p>
+        </p:txBody>
+      </p:sp>
     </p:spTree>
     <p:extLst>
       <p:ext uri="{BB962C8B-B14F-4D97-AF65-F5344CB8AC3E}">
-        <p14:creationId xmlns:p14="http://schemas.microsoft.com/office/powerpoint/2010/main" val="4057030523"/>
+        <p14:creationId xmlns:p14="http://schemas.microsoft.com/office/powerpoint/2010/main" val="1979839893"/>
       </p:ext>
     </p:extLst>
   </p:cSld>
@@ -12932,86 +11925,6 @@
 </a:theme>
 </file>
 
-<file path=ppt/webextensions/webextension1.xml><?xml version="1.0" encoding="utf-8"?>
-<we:webextension xmlns:we="http://schemas.microsoft.com/office/webextensions/webextension/2010/11" id="{E1D6287C-E119-4EB4-9553-4AA90814C03A}">
-  <we:reference id="wa200008736" version="1.0.0.0" store="en-US" storeType="OMEX"/>
-  <we:alternateReferences>
-    <we:reference id="WA200008736" version="1.0.0.0" store="WA200008736" storeType="OMEX"/>
-  </we:alternateReferences>
-  <we:properties>
-    <we:property name="dtServerUrl" value="&quot;http://localhost:3710&quot;"/>
-    <we:property name="dtDemoId" value="&quot;demo-mi7wlce4-lh10&quot;"/>
-    <we:property name="dtAddInSlideId" value="&quot;7&quot;"/>
-  </we:properties>
-  <we:bindings/>
-  <we:snapshot xmlns:r="http://schemas.openxmlformats.org/officeDocument/2006/relationships" r:embed="rId1"/>
-</we:webextension>
-</file>
-
-<file path=ppt/webextensions/webextension2.xml><?xml version="1.0" encoding="utf-8"?>
-<we:webextension xmlns:we="http://schemas.microsoft.com/office/webextensions/webextension/2010/11" id="{7FC1C454-888A-44F4-811F-6E89BE8663C7}">
-  <we:reference id="wa200008736" version="1.0.0.0" store="en-US" storeType="OMEX"/>
-  <we:alternateReferences>
-    <we:reference id="WA200008736" version="1.0.0.0" store="WA200008736" storeType="OMEX"/>
-  </we:alternateReferences>
-  <we:properties>
-    <we:property name="dtAddInSlideId" value="&quot;9&quot;"/>
-    <we:property name="dtDemoId" value="&quot;demo-mi67d68t-rc01&quot;"/>
-    <we:property name="dtServerUrl" value="&quot;http://localhost:3710&quot;"/>
-  </we:properties>
-  <we:bindings/>
-  <we:snapshot xmlns:r="http://schemas.openxmlformats.org/officeDocument/2006/relationships" r:embed="rId1"/>
-</we:webextension>
-</file>
-
-<file path=ppt/webextensions/webextension3.xml><?xml version="1.0" encoding="utf-8"?>
-<we:webextension xmlns:we="http://schemas.microsoft.com/office/webextensions/webextension/2010/11" id="{950736F9-0746-4D9C-B16C-A847C1836C07}">
-  <we:reference id="wa200008736" version="1.0.0.0" store="en-US" storeType="OMEX"/>
-  <we:alternateReferences>
-    <we:reference id="WA200008736" version="1.0.0.0" store="WA200008736" storeType="OMEX"/>
-  </we:alternateReferences>
-  <we:properties>
-    <we:property name="dtAddInSlideId" value="&quot;11&quot;"/>
-    <we:property name="dtDemoId" value="&quot;demo-mi665oql-prba&quot;"/>
-    <we:property name="dtServerUrl" value="&quot;http://localhost:3710&quot;"/>
-  </we:properties>
-  <we:bindings/>
-  <we:snapshot xmlns:r="http://schemas.openxmlformats.org/officeDocument/2006/relationships" r:embed="rId1"/>
-</we:webextension>
-</file>
-
-<file path=ppt/webextensions/webextension4.xml><?xml version="1.0" encoding="utf-8"?>
-<we:webextension xmlns:we="http://schemas.microsoft.com/office/webextensions/webextension/2010/11" id="{C53A98D1-B4A2-48F2-861F-980AF20D6155}">
-  <we:reference id="wa200008736" version="1.0.0.0" store="en-US" storeType="OMEX"/>
-  <we:alternateReferences>
-    <we:reference id="WA200008736" version="1.0.0.0" store="WA200008736" storeType="OMEX"/>
-  </we:alternateReferences>
-  <we:properties>
-    <we:property name="dtAddInSlideId" value="&quot;13&quot;"/>
-    <we:property name="dtDemoId" value="&quot;demo-mi66cnpy-h2tu&quot;"/>
-    <we:property name="dtServerUrl" value="&quot;http://localhost:3710&quot;"/>
-  </we:properties>
-  <we:bindings/>
-  <we:snapshot xmlns:r="http://schemas.openxmlformats.org/officeDocument/2006/relationships" r:embed="rId1"/>
-</we:webextension>
-</file>
-
-<file path=ppt/webextensions/webextension5.xml><?xml version="1.0" encoding="utf-8"?>
-<we:webextension xmlns:we="http://schemas.microsoft.com/office/webextensions/webextension/2010/11" id="{50E8D167-3FBD-40D7-B0B1-4EA29FCBB70E}">
-  <we:reference id="wa200008736" version="1.0.0.0" store="en-US" storeType="OMEX"/>
-  <we:alternateReferences>
-    <we:reference id="WA200008736" version="1.0.0.0" store="WA200008736" storeType="OMEX"/>
-  </we:alternateReferences>
-  <we:properties>
-    <we:property name="dtAddInSlideId" value="&quot;15&quot;"/>
-    <we:property name="dtDemoId" value="&quot;demo-mi66lt1n-v79y&quot;"/>
-    <we:property name="dtServerUrl" value="&quot;http://localhost:3710&quot;"/>
-  </we:properties>
-  <we:bindings/>
-  <we:snapshot xmlns:r="http://schemas.openxmlformats.org/officeDocument/2006/relationships" r:embed="rId1"/>
-</we:webextension>
-</file>
-
 <file path=customXml/item1.xml><?xml version="1.0" encoding="utf-8"?>
 <?mso-contentType ?>
 <FormTemplates xmlns="http://schemas.microsoft.com/sharepoint/v3/contenttype/forms">

</xml_diff>